<commit_message>
chore: remove the CAPTCHA subsystem
</commit_message>
<xml_diff>
--- a/paparan/Laravel-Security-Monitor-Bulwark.pptx
+++ b/paparan/Laravel-Security-Monitor-Bulwark.pptx
@@ -24,7 +24,6 @@
     <p:sldId id="272" r:id="rId18"/>
     <p:sldId id="273" r:id="rId19"/>
     <p:sldId id="274" r:id="rId20"/>
-    <p:sldId id="275" r:id="rId21"/>
   </p:sldIdLst>
   <p:sldSz cx="12192000" cy="6858000" type="screen16x9"/>
   <p:notesSz cx="6858000" cy="9144000"/>
@@ -371,7 +370,7 @@
                   <a:srgbClr val="0F172A"/>
                 </a:solidFill>
               </a:rPr>
-              <a:t>Streaming Access Log Scanner</a:t>
+              <a:t>Appeal Tickets &amp; Session Tracking</a:t>
             </a:r>
           </a:p>
         </p:txBody>
@@ -438,49 +437,49 @@
                   <a:srgbClr val="1E293B"/>
                 </a:solidFill>
               </a:rPr>
-              <a:t>Membaca log Apache/Nginx baris-per-baris via generator — konsumsi RAM stabil di bawah 15 MB.</a:t>
-            </a:r>
-          </a:p>
-          <a:p>
-            <a:pPr marL="285750" indent="-285750">
-              <a:buFont typeface="Arial"/>
-              <a:buChar char="•"/>
-            </a:pPr>
-            <a:r>
-              <a:rPr lang="en-US" sz="1700" dirty="0">
-                <a:solidFill>
-                  <a:srgbClr val="1E293B"/>
-                </a:solidFill>
-              </a:rPr>
-              <a:t>Menangkap penyerang yang ditolak web server sebelum request mencapai PHP.</a:t>
-            </a:r>
-          </a:p>
-          <a:p>
-            <a:pPr marL="285750" indent="-285750">
-              <a:buFont typeface="Arial"/>
-              <a:buChar char="•"/>
-            </a:pPr>
-            <a:r>
-              <a:rPr lang="en-US" sz="1700" dirty="0">
-                <a:solidFill>
-                  <a:srgbClr val="1E293B"/>
-                </a:solidFill>
-              </a:rPr>
-              <a:t>Auto-block IP langsung dari log mentah.</a:t>
-            </a:r>
-          </a:p>
-          <a:p>
-            <a:pPr marL="285750" indent="-285750">
-              <a:buFont typeface="Arial"/>
-              <a:buChar char="•"/>
-            </a:pPr>
-            <a:r>
-              <a:rPr lang="en-US" sz="1700" dirty="0">
-                <a:solidFill>
-                  <a:srgbClr val="1E293B"/>
-                </a:solidFill>
-              </a:rPr>
-              <a:t>Dijadwalkan harian (cron) melalui Laravel Scheduler.</a:t>
+              <a:t>Endpoint publik untuk mengajukan banding buka blokir beserta pelacakan status.</a:t>
+            </a:r>
+          </a:p>
+          <a:p>
+            <a:pPr marL="285750" indent="-285750">
+              <a:buFont typeface="Arial"/>
+              <a:buChar char="•"/>
+            </a:pPr>
+            <a:r>
+              <a:rPr lang="en-US" sz="1700" dirty="0">
+                <a:solidFill>
+                  <a:srgbClr val="1E293B"/>
+                </a:solidFill>
+              </a:rPr>
+              <a:t>Rate-limit 30 menit untuk mencegah penyalahgunaan.</a:t>
+            </a:r>
+          </a:p>
+          <a:p>
+            <a:pPr marL="285750" indent="-285750">
+              <a:buFont typeface="Arial"/>
+              <a:buChar char="•"/>
+            </a:pPr>
+            <a:r>
+              <a:rPr lang="en-US" sz="1700" dirty="0">
+                <a:solidFill>
+                  <a:srgbClr val="1E293B"/>
+                </a:solidFill>
+              </a:rPr>
+              <a:t>Persetujuan admin otomatis mencabut karantina dan menambahkan ke whitelist.</a:t>
+            </a:r>
+          </a:p>
+          <a:p>
+            <a:pPr marL="285750" indent="-285750">
+              <a:buFont typeface="Arial"/>
+              <a:buChar char="•"/>
+            </a:pPr>
+            <a:r>
+              <a:rPr lang="en-US" sz="1700" dirty="0">
+                <a:solidFill>
+                  <a:srgbClr val="1E293B"/>
+                </a:solidFill>
+              </a:rPr>
+              <a:t>Pelacakan sesi aktif dengan heartbeat aktivitas yang di-throttle (45 detik).</a:t>
             </a:r>
           </a:p>
         </p:txBody>
@@ -569,7 +568,7 @@
                   <a:srgbClr val="0F172A"/>
                 </a:solidFill>
               </a:rPr>
-              <a:t>Appeal Tickets &amp; Session Tracking</a:t>
+              <a:t>Arsitektur &amp; Integrasi</a:t>
             </a:r>
           </a:p>
         </p:txBody>
@@ -636,49 +635,275 @@
                   <a:srgbClr val="1E293B"/>
                 </a:solidFill>
               </a:rPr>
-              <a:t>Endpoint publik untuk mengajukan banding buka blokir beserta pelacakan status.</a:t>
-            </a:r>
-          </a:p>
-          <a:p>
-            <a:pPr marL="285750" indent="-285750">
-              <a:buFont typeface="Arial"/>
-              <a:buChar char="•"/>
-            </a:pPr>
-            <a:r>
-              <a:rPr lang="en-US" sz="1700" dirty="0">
-                <a:solidFill>
-                  <a:srgbClr val="1E293B"/>
-                </a:solidFill>
-              </a:rPr>
-              <a:t>Rate-limit 30 menit untuk mencegah penyalahgunaan.</a:t>
-            </a:r>
-          </a:p>
-          <a:p>
-            <a:pPr marL="285750" indent="-285750">
-              <a:buFont typeface="Arial"/>
-              <a:buChar char="•"/>
-            </a:pPr>
-            <a:r>
-              <a:rPr lang="en-US" sz="1700" dirty="0">
-                <a:solidFill>
-                  <a:srgbClr val="1E293B"/>
-                </a:solidFill>
-              </a:rPr>
-              <a:t>Persetujuan admin otomatis mencabut karantina dan menambahkan ke whitelist.</a:t>
-            </a:r>
-          </a:p>
-          <a:p>
-            <a:pPr marL="285750" indent="-285750">
-              <a:buFont typeface="Arial"/>
-              <a:buChar char="•"/>
-            </a:pPr>
-            <a:r>
-              <a:rPr lang="en-US" sz="1700" dirty="0">
-                <a:solidFill>
-                  <a:srgbClr val="1E293B"/>
-                </a:solidFill>
-              </a:rPr>
-              <a:t>Pelacakan sesi aktif dengan heartbeat aktivitas yang di-throttle (45 detik).</a:t>
+              <a:t>Auto-discovery: </a:t>
+            </a:r>
+            <a:r>
+              <a:rPr lang="en-US" sz="1600" dirty="0">
+                <a:solidFill>
+                  <a:srgbClr val="0EA5E9"/>
+                </a:solidFill>
+                <a:latin typeface="Consolas"/>
+                <a:cs typeface="Consolas"/>
+              </a:rPr>
+              <a:t>SecurityMonitorServiceProvider</a:t>
+            </a:r>
+            <a:r>
+              <a:rPr lang="en-US" sz="1700" dirty="0">
+                <a:solidFill>
+                  <a:srgbClr val="1E293B"/>
+                </a:solidFill>
+              </a:rPr>
+              <a:t> + Facade </a:t>
+            </a:r>
+            <a:r>
+              <a:rPr lang="en-US" sz="1600" dirty="0">
+                <a:solidFill>
+                  <a:srgbClr val="0EA5E9"/>
+                </a:solidFill>
+                <a:latin typeface="Consolas"/>
+                <a:cs typeface="Consolas"/>
+              </a:rPr>
+              <a:t>SecurityMonitor</a:t>
+            </a:r>
+            <a:r>
+              <a:rPr lang="en-US" sz="1700" dirty="0">
+                <a:solidFill>
+                  <a:srgbClr val="1E293B"/>
+                </a:solidFill>
+              </a:rPr>
+              <a:t>.</a:t>
+            </a:r>
+          </a:p>
+          <a:p>
+            <a:pPr marL="285750" indent="-285750">
+              <a:buFont typeface="Arial"/>
+              <a:buChar char="•"/>
+            </a:pPr>
+            <a:r>
+              <a:rPr lang="en-US" sz="1700" dirty="0">
+                <a:solidFill>
+                  <a:srgbClr val="1E293B"/>
+                </a:solidFill>
+              </a:rPr>
+              <a:t>Trait </a:t>
+            </a:r>
+            <a:r>
+              <a:rPr lang="en-US" sz="1600" dirty="0">
+                <a:solidFill>
+                  <a:srgbClr val="0EA5E9"/>
+                </a:solidFill>
+                <a:latin typeface="Consolas"/>
+                <a:cs typeface="Consolas"/>
+              </a:rPr>
+              <a:t>HasSecurityRelations</a:t>
+            </a:r>
+            <a:r>
+              <a:rPr lang="en-US" sz="1700" dirty="0">
+                <a:solidFill>
+                  <a:srgbClr val="1E293B"/>
+                </a:solidFill>
+              </a:rPr>
+              <a:t> pada model </a:t>
+            </a:r>
+            <a:r>
+              <a:rPr lang="en-US" sz="1600" dirty="0">
+                <a:solidFill>
+                  <a:srgbClr val="0EA5E9"/>
+                </a:solidFill>
+                <a:latin typeface="Consolas"/>
+                <a:cs typeface="Consolas"/>
+              </a:rPr>
+              <a:t>User</a:t>
+            </a:r>
+            <a:r>
+              <a:rPr lang="en-US" sz="1700" dirty="0">
+                <a:solidFill>
+                  <a:srgbClr val="1E293B"/>
+                </a:solidFill>
+              </a:rPr>
+              <a:t> host.</a:t>
+            </a:r>
+          </a:p>
+          <a:p>
+            <a:pPr marL="285750" indent="-285750">
+              <a:buFont typeface="Arial"/>
+              <a:buChar char="•"/>
+            </a:pPr>
+            <a:r>
+              <a:rPr lang="en-US" sz="1700" dirty="0">
+                <a:solidFill>
+                  <a:srgbClr val="1E293B"/>
+                </a:solidFill>
+              </a:rPr>
+              <a:t>Middleware teraliasing: </a:t>
+            </a:r>
+            <a:r>
+              <a:rPr lang="en-US" sz="1600" dirty="0">
+                <a:solidFill>
+                  <a:srgbClr val="0EA5E9"/>
+                </a:solidFill>
+                <a:latin typeface="Consolas"/>
+                <a:cs typeface="Consolas"/>
+              </a:rPr>
+              <a:t>security.block</a:t>
+            </a:r>
+            <a:r>
+              <a:rPr lang="en-US" sz="1700" dirty="0">
+                <a:solidFill>
+                  <a:srgbClr val="1E293B"/>
+                </a:solidFill>
+              </a:rPr>
+              <a:t>, </a:t>
+            </a:r>
+            <a:r>
+              <a:rPr lang="en-US" sz="1600" dirty="0">
+                <a:solidFill>
+                  <a:srgbClr val="0EA5E9"/>
+                </a:solidFill>
+                <a:latin typeface="Consolas"/>
+                <a:cs typeface="Consolas"/>
+              </a:rPr>
+              <a:t>security.detect</a:t>
+            </a:r>
+            <a:r>
+              <a:rPr lang="en-US" sz="1700" dirty="0">
+                <a:solidFill>
+                  <a:srgbClr val="1E293B"/>
+                </a:solidFill>
+              </a:rPr>
+              <a:t>, </a:t>
+            </a:r>
+            <a:r>
+              <a:rPr lang="en-US" sz="1600" dirty="0">
+                <a:solidFill>
+                  <a:srgbClr val="0EA5E9"/>
+                </a:solidFill>
+                <a:latin typeface="Consolas"/>
+                <a:cs typeface="Consolas"/>
+              </a:rPr>
+              <a:t>security.admin</a:t>
+            </a:r>
+            <a:r>
+              <a:rPr lang="en-US" sz="1700" dirty="0">
+                <a:solidFill>
+                  <a:srgbClr val="1E293B"/>
+                </a:solidFill>
+              </a:rPr>
+              <a:t>, </a:t>
+            </a:r>
+            <a:r>
+              <a:rPr lang="en-US" sz="1600" dirty="0">
+                <a:solidFill>
+                  <a:srgbClr val="0EA5E9"/>
+                </a:solidFill>
+                <a:latin typeface="Consolas"/>
+                <a:cs typeface="Consolas"/>
+              </a:rPr>
+              <a:t>security.activity</a:t>
+            </a:r>
+            <a:r>
+              <a:rPr lang="en-US" sz="1700" dirty="0">
+                <a:solidFill>
+                  <a:srgbClr val="1E293B"/>
+                </a:solidFill>
+              </a:rPr>
+              <a:t>.</a:t>
+            </a:r>
+          </a:p>
+          <a:p>
+            <a:pPr marL="285750" indent="-285750">
+              <a:buFont typeface="Arial"/>
+              <a:buChar char="•"/>
+            </a:pPr>
+            <a:r>
+              <a:rPr lang="en-US" sz="1700" dirty="0">
+                <a:solidFill>
+                  <a:srgbClr val="1E293B"/>
+                </a:solidFill>
+              </a:rPr>
+              <a:t>Gate </a:t>
+            </a:r>
+            <a:r>
+              <a:rPr lang="en-US" sz="1600" dirty="0">
+                <a:solidFill>
+                  <a:srgbClr val="0EA5E9"/>
+                </a:solidFill>
+                <a:latin typeface="Consolas"/>
+                <a:cs typeface="Consolas"/>
+              </a:rPr>
+              <a:t>manage-security-monitor</a:t>
+            </a:r>
+            <a:r>
+              <a:rPr lang="en-US" sz="1700" dirty="0">
+                <a:solidFill>
+                  <a:srgbClr val="1E293B"/>
+                </a:solidFill>
+              </a:rPr>
+              <a:t> untuk otorisasi admin.</a:t>
+            </a:r>
+          </a:p>
+          <a:p>
+            <a:pPr marL="285750" indent="-285750">
+              <a:buFont typeface="Arial"/>
+              <a:buChar char="•"/>
+            </a:pPr>
+            <a:r>
+              <a:rPr lang="en-US" sz="1700" dirty="0">
+                <a:solidFill>
+                  <a:srgbClr val="1E293B"/>
+                </a:solidFill>
+              </a:rPr>
+              <a:t>Model &amp; nama tabel dinamis via config — tidak ada </a:t>
+            </a:r>
+            <a:r>
+              <a:rPr lang="en-US" sz="1600" dirty="0">
+                <a:solidFill>
+                  <a:srgbClr val="0EA5E9"/>
+                </a:solidFill>
+                <a:latin typeface="Consolas"/>
+                <a:cs typeface="Consolas"/>
+              </a:rPr>
+              <a:t>User</a:t>
+            </a:r>
+            <a:r>
+              <a:rPr lang="en-US" sz="1700" dirty="0">
+                <a:solidFill>
+                  <a:srgbClr val="1E293B"/>
+                </a:solidFill>
+              </a:rPr>
+              <a:t> atau tabel yang di-hardcode.</a:t>
+            </a:r>
+          </a:p>
+          <a:p>
+            <a:pPr marL="285750" indent="-285750">
+              <a:buFont typeface="Arial"/>
+              <a:buChar char="•"/>
+            </a:pPr>
+            <a:r>
+              <a:rPr lang="en-US" sz="1700" dirty="0">
+                <a:solidFill>
+                  <a:srgbClr val="1E293B"/>
+                </a:solidFill>
+              </a:rPr>
+              <a:t>Zero-touch opsional: </a:t>
+            </a:r>
+            <a:r>
+              <a:rPr lang="en-US" sz="1600" dirty="0">
+                <a:solidFill>
+                  <a:srgbClr val="0EA5E9"/>
+                </a:solidFill>
+                <a:latin typeface="Consolas"/>
+                <a:cs typeface="Consolas"/>
+              </a:rPr>
+              <a:t>SECURITY_AUTO_REGISTER_MIDDLEWARE=true</a:t>
+            </a:r>
+            <a:r>
+              <a:rPr lang="en-US" sz="1700" dirty="0">
+                <a:solidFill>
+                  <a:srgbClr val="1E293B"/>
+                </a:solidFill>
+              </a:rPr>
+              <a:t>.</a:t>
             </a:r>
           </a:p>
         </p:txBody>
@@ -767,7 +992,7 @@
                   <a:srgbClr val="0F172A"/>
                 </a:solidFill>
               </a:rPr>
-              <a:t>Arsitektur &amp; Integrasi</a:t>
+              <a:t>Headless REST API</a:t>
             </a:r>
           </a:p>
         </p:txBody>
@@ -834,143 +1059,53 @@
                   <a:srgbClr val="1E293B"/>
                 </a:solidFill>
               </a:rPr>
-              <a:t>Auto-discovery: </a:t>
-            </a:r>
-            <a:r>
-              <a:rPr lang="en-US" sz="1600" dirty="0">
-                <a:solidFill>
-                  <a:srgbClr val="0EA5E9"/>
-                </a:solidFill>
-                <a:latin typeface="Consolas"/>
-                <a:cs typeface="Consolas"/>
-              </a:rPr>
-              <a:t>SecurityMonitorServiceProvider</a:t>
-            </a:r>
-            <a:r>
-              <a:rPr lang="en-US" sz="1700" dirty="0">
-                <a:solidFill>
-                  <a:srgbClr val="1E293B"/>
-                </a:solidFill>
-              </a:rPr>
-              <a:t> + Facade </a:t>
-            </a:r>
-            <a:r>
-              <a:rPr lang="en-US" sz="1600" dirty="0">
-                <a:solidFill>
-                  <a:srgbClr val="0EA5E9"/>
-                </a:solidFill>
-                <a:latin typeface="Consolas"/>
-                <a:cs typeface="Consolas"/>
-              </a:rPr>
-              <a:t>SecurityMonitor</a:t>
-            </a:r>
-            <a:r>
-              <a:rPr lang="en-US" sz="1700" dirty="0">
-                <a:solidFill>
-                  <a:srgbClr val="1E293B"/>
-                </a:solidFill>
-              </a:rPr>
-              <a:t>.</a:t>
-            </a:r>
-          </a:p>
-          <a:p>
-            <a:pPr marL="285750" indent="-285750">
-              <a:buFont typeface="Arial"/>
-              <a:buChar char="•"/>
-            </a:pPr>
-            <a:r>
-              <a:rPr lang="en-US" sz="1700" dirty="0">
-                <a:solidFill>
-                  <a:srgbClr val="1E293B"/>
-                </a:solidFill>
-              </a:rPr>
-              <a:t>Trait </a:t>
-            </a:r>
-            <a:r>
-              <a:rPr lang="en-US" sz="1600" dirty="0">
-                <a:solidFill>
-                  <a:srgbClr val="0EA5E9"/>
-                </a:solidFill>
-                <a:latin typeface="Consolas"/>
-                <a:cs typeface="Consolas"/>
-              </a:rPr>
-              <a:t>HasSecurityRelations</a:t>
-            </a:r>
-            <a:r>
-              <a:rPr lang="en-US" sz="1700" dirty="0">
-                <a:solidFill>
-                  <a:srgbClr val="1E293B"/>
-                </a:solidFill>
-              </a:rPr>
-              <a:t> pada model </a:t>
-            </a:r>
-            <a:r>
-              <a:rPr lang="en-US" sz="1600" dirty="0">
-                <a:solidFill>
-                  <a:srgbClr val="0EA5E9"/>
-                </a:solidFill>
-                <a:latin typeface="Consolas"/>
-                <a:cs typeface="Consolas"/>
-              </a:rPr>
-              <a:t>User</a:t>
-            </a:r>
-            <a:r>
-              <a:rPr lang="en-US" sz="1700" dirty="0">
-                <a:solidFill>
-                  <a:srgbClr val="1E293B"/>
-                </a:solidFill>
-              </a:rPr>
-              <a:t> host.</a:t>
-            </a:r>
-          </a:p>
-          <a:p>
-            <a:pPr marL="285750" indent="-285750">
-              <a:buFont typeface="Arial"/>
-              <a:buChar char="•"/>
-            </a:pPr>
-            <a:r>
-              <a:rPr lang="en-US" sz="1700" dirty="0">
-                <a:solidFill>
-                  <a:srgbClr val="1E293B"/>
-                </a:solidFill>
-              </a:rPr>
-              <a:t>Middleware teraliasing: </a:t>
-            </a:r>
-            <a:r>
-              <a:rPr lang="en-US" sz="1600" dirty="0">
-                <a:solidFill>
-                  <a:srgbClr val="0EA5E9"/>
-                </a:solidFill>
-                <a:latin typeface="Consolas"/>
-                <a:cs typeface="Consolas"/>
-              </a:rPr>
-              <a:t>security.block</a:t>
-            </a:r>
-            <a:r>
-              <a:rPr lang="en-US" sz="1700" dirty="0">
-                <a:solidFill>
-                  <a:srgbClr val="1E293B"/>
-                </a:solidFill>
-              </a:rPr>
-              <a:t>, </a:t>
-            </a:r>
-            <a:r>
-              <a:rPr lang="en-US" sz="1600" dirty="0">
-                <a:solidFill>
-                  <a:srgbClr val="0EA5E9"/>
-                </a:solidFill>
-                <a:latin typeface="Consolas"/>
-                <a:cs typeface="Consolas"/>
-              </a:rPr>
-              <a:t>security.detect</a:t>
-            </a:r>
-            <a:r>
-              <a:rPr lang="en-US" sz="1700" dirty="0">
-                <a:solidFill>
-                  <a:srgbClr val="1E293B"/>
-                </a:solidFill>
-              </a:rPr>
-              <a:t>, </a:t>
+              <a:t>Publik: submit &amp; cek status tiket banding.</a:t>
+            </a:r>
+          </a:p>
+          <a:p>
+            <a:pPr marL="285750" indent="-285750">
+              <a:buFont typeface="Arial"/>
+              <a:buChar char="•"/>
+            </a:pPr>
+            <a:r>
+              <a:rPr lang="en-US" sz="1700" dirty="0">
+                <a:solidFill>
+                  <a:srgbClr val="1E293B"/>
+                </a:solidFill>
+              </a:rPr>
+              <a:t>Pengguna terautentikasi: menyimpan IP saat ini sebagai IP terpercaya.</a:t>
+            </a:r>
+          </a:p>
+          <a:p>
+            <a:pPr marL="285750" indent="-285750">
+              <a:buFont typeface="Arial"/>
+              <a:buChar char="•"/>
+            </a:pPr>
+            <a:r>
+              <a:rPr lang="en-US" sz="1700" dirty="0">
+                <a:solidFill>
+                  <a:srgbClr val="1E293B"/>
+                </a:solidFill>
+              </a:rPr>
+              <a:t>Admin (</a:t>
+            </a:r>
+            <a:r>
+              <a:rPr lang="en-US" sz="1600" dirty="0">
+                <a:solidFill>
+                  <a:srgbClr val="0EA5E9"/>
+                </a:solidFill>
+                <a:latin typeface="Consolas"/>
+                <a:cs typeface="Consolas"/>
+              </a:rPr>
+              <a:t>auth</a:t>
+            </a:r>
+            <a:r>
+              <a:rPr lang="en-US" sz="1700" dirty="0">
+                <a:solidFill>
+                  <a:srgbClr val="1E293B"/>
+                </a:solidFill>
+              </a:rPr>
+              <a:t> + </a:t>
             </a:r>
             <a:r>
               <a:rPr lang="en-US" sz="1600" dirty="0">
@@ -988,121 +1123,21 @@
                   <a:srgbClr val="1E293B"/>
                 </a:solidFill>
               </a:rPr>
-              <a:t>, </a:t>
-            </a:r>
-            <a:r>
-              <a:rPr lang="en-US" sz="1600" dirty="0">
-                <a:solidFill>
-                  <a:srgbClr val="0EA5E9"/>
-                </a:solidFill>
-                <a:latin typeface="Consolas"/>
-                <a:cs typeface="Consolas"/>
-              </a:rPr>
-              <a:t>security.activity</a:t>
-            </a:r>
-            <a:r>
-              <a:rPr lang="en-US" sz="1700" dirty="0">
-                <a:solidFill>
-                  <a:srgbClr val="1E293B"/>
-                </a:solidFill>
-              </a:rPr>
-              <a:t>.</a:t>
-            </a:r>
-          </a:p>
-          <a:p>
-            <a:pPr marL="285750" indent="-285750">
-              <a:buFont typeface="Arial"/>
-              <a:buChar char="•"/>
-            </a:pPr>
-            <a:r>
-              <a:rPr lang="en-US" sz="1700" dirty="0">
-                <a:solidFill>
-                  <a:srgbClr val="1E293B"/>
-                </a:solidFill>
-              </a:rPr>
-              <a:t>Gate </a:t>
-            </a:r>
-            <a:r>
-              <a:rPr lang="en-US" sz="1600" dirty="0">
-                <a:solidFill>
-                  <a:srgbClr val="0EA5E9"/>
-                </a:solidFill>
-                <a:latin typeface="Consolas"/>
-                <a:cs typeface="Consolas"/>
-              </a:rPr>
-              <a:t>manage-security-monitor</a:t>
-            </a:r>
-            <a:r>
-              <a:rPr lang="en-US" sz="1700" dirty="0">
-                <a:solidFill>
-                  <a:srgbClr val="1E293B"/>
-                </a:solidFill>
-              </a:rPr>
-              <a:t> untuk otorisasi admin.</a:t>
-            </a:r>
-          </a:p>
-          <a:p>
-            <a:pPr marL="285750" indent="-285750">
-              <a:buFont typeface="Arial"/>
-              <a:buChar char="•"/>
-            </a:pPr>
-            <a:r>
-              <a:rPr lang="en-US" sz="1700" dirty="0">
-                <a:solidFill>
-                  <a:srgbClr val="1E293B"/>
-                </a:solidFill>
-              </a:rPr>
-              <a:t>Model &amp; nama tabel dinamis via config — tidak ada </a:t>
-            </a:r>
-            <a:r>
-              <a:rPr lang="en-US" sz="1600" dirty="0">
-                <a:solidFill>
-                  <a:srgbClr val="0EA5E9"/>
-                </a:solidFill>
-                <a:latin typeface="Consolas"/>
-                <a:cs typeface="Consolas"/>
-              </a:rPr>
-              <a:t>User</a:t>
-            </a:r>
-            <a:r>
-              <a:rPr lang="en-US" sz="1700" dirty="0">
-                <a:solidFill>
-                  <a:srgbClr val="1E293B"/>
-                </a:solidFill>
-              </a:rPr>
-              <a:t> atau tabel yang di-hardcode.</a:t>
-            </a:r>
-          </a:p>
-          <a:p>
-            <a:pPr marL="285750" indent="-285750">
-              <a:buFont typeface="Arial"/>
-              <a:buChar char="•"/>
-            </a:pPr>
-            <a:r>
-              <a:rPr lang="en-US" sz="1700" dirty="0">
-                <a:solidFill>
-                  <a:srgbClr val="1E293B"/>
-                </a:solidFill>
-              </a:rPr>
-              <a:t>Zero-touch opsional: </a:t>
-            </a:r>
-            <a:r>
-              <a:rPr lang="en-US" sz="1600" dirty="0">
-                <a:solidFill>
-                  <a:srgbClr val="0EA5E9"/>
-                </a:solidFill>
-                <a:latin typeface="Consolas"/>
-                <a:cs typeface="Consolas"/>
-              </a:rPr>
-              <a:t>SECURITY_AUTO_REGISTER_MIDDLEWARE=true</a:t>
-            </a:r>
-            <a:r>
-              <a:rPr lang="en-US" sz="1700" dirty="0">
-                <a:solidFill>
-                  <a:srgbClr val="1E293B"/>
-                </a:solidFill>
-              </a:rPr>
-              <a:t>.</a:t>
+              <a:t>): logs, blocked-ips, server audit, sessions, tickets.</a:t>
+            </a:r>
+          </a:p>
+          <a:p>
+            <a:pPr marL="285750" indent="-285750">
+              <a:buFont typeface="Arial"/>
+              <a:buChar char="•"/>
+            </a:pPr>
+            <a:r>
+              <a:rPr lang="en-US" sz="1700" dirty="0">
+                <a:solidFill>
+                  <a:srgbClr val="1E293B"/>
+                </a:solidFill>
+              </a:rPr>
+              <a:t>Envelope JSON konsisten dengan status HTTP yang tepat.</a:t>
             </a:r>
           </a:p>
         </p:txBody>
@@ -1191,7 +1226,7 @@
                   <a:srgbClr val="0F172A"/>
                 </a:solidFill>
               </a:rPr>
-              <a:t>Headless REST API</a:t>
+              <a:t>CLI Artisan &amp; Automation</a:t>
             </a:r>
           </a:p>
         </p:txBody>
@@ -1253,90 +1288,156 @@
               <a:buChar char="•"/>
             </a:pPr>
             <a:r>
-              <a:rPr lang="en-US" sz="1700" dirty="0">
-                <a:solidFill>
-                  <a:srgbClr val="1E293B"/>
-                </a:solidFill>
-              </a:rPr>
-              <a:t>Publik: captcha, verifikasi captcha, submit &amp; cek status tiket banding.</a:t>
-            </a:r>
-          </a:p>
-          <a:p>
-            <a:pPr marL="285750" indent="-285750">
-              <a:buFont typeface="Arial"/>
-              <a:buChar char="•"/>
-            </a:pPr>
-            <a:r>
-              <a:rPr lang="en-US" sz="1700" dirty="0">
-                <a:solidFill>
-                  <a:srgbClr val="1E293B"/>
-                </a:solidFill>
-              </a:rPr>
-              <a:t>Pengguna terautentikasi: menyimpan IP saat ini sebagai IP terpercaya.</a:t>
-            </a:r>
-          </a:p>
-          <a:p>
-            <a:pPr marL="285750" indent="-285750">
-              <a:buFont typeface="Arial"/>
-              <a:buChar char="•"/>
-            </a:pPr>
-            <a:r>
-              <a:rPr lang="en-US" sz="1700" dirty="0">
-                <a:solidFill>
-                  <a:srgbClr val="1E293B"/>
-                </a:solidFill>
-              </a:rPr>
-              <a:t>Admin (</a:t>
-            </a:r>
-            <a:r>
-              <a:rPr lang="en-US" sz="1600" dirty="0">
-                <a:solidFill>
-                  <a:srgbClr val="0EA5E9"/>
-                </a:solidFill>
-                <a:latin typeface="Consolas"/>
-                <a:cs typeface="Consolas"/>
-              </a:rPr>
-              <a:t>auth</a:t>
-            </a:r>
-            <a:r>
-              <a:rPr lang="en-US" sz="1700" dirty="0">
-                <a:solidFill>
-                  <a:srgbClr val="1E293B"/>
-                </a:solidFill>
-              </a:rPr>
-              <a:t> + </a:t>
-            </a:r>
-            <a:r>
-              <a:rPr lang="en-US" sz="1600" dirty="0">
-                <a:solidFill>
-                  <a:srgbClr val="0EA5E9"/>
-                </a:solidFill>
-                <a:latin typeface="Consolas"/>
-                <a:cs typeface="Consolas"/>
-              </a:rPr>
-              <a:t>security.admin</a:t>
-            </a:r>
-            <a:r>
-              <a:rPr lang="en-US" sz="1700" dirty="0">
-                <a:solidFill>
-                  <a:srgbClr val="1E293B"/>
-                </a:solidFill>
-              </a:rPr>
-              <a:t>): logs, blocked-ips, server audit, sessions, tickets.</a:t>
-            </a:r>
-          </a:p>
-          <a:p>
-            <a:pPr marL="285750" indent="-285750">
-              <a:buFont typeface="Arial"/>
-              <a:buChar char="•"/>
-            </a:pPr>
-            <a:r>
-              <a:rPr lang="en-US" sz="1700" dirty="0">
-                <a:solidFill>
-                  <a:srgbClr val="1E293B"/>
-                </a:solidFill>
-              </a:rPr>
-              <a:t>Envelope JSON konsisten dengan status HTTP yang tepat.</a:t>
+              <a:rPr lang="en-US" sz="1600" dirty="0">
+                <a:solidFill>
+                  <a:srgbClr val="0EA5E9"/>
+                </a:solidFill>
+                <a:latin typeface="Consolas"/>
+                <a:cs typeface="Consolas"/>
+              </a:rPr>
+              <a:t>security:install</a:t>
+            </a:r>
+            <a:r>
+              <a:rPr lang="en-US" sz="1700" dirty="0">
+                <a:solidFill>
+                  <a:srgbClr val="1E293B"/>
+                </a:solidFill>
+              </a:rPr>
+              <a:t> — publikasi aset + hardening interaktif.</a:t>
+            </a:r>
+          </a:p>
+          <a:p>
+            <a:pPr marL="285750" indent="-285750">
+              <a:buFont typeface="Arial"/>
+              <a:buChar char="•"/>
+            </a:pPr>
+            <a:r>
+              <a:rPr lang="en-US" sz="1600" dirty="0">
+                <a:solidFill>
+                  <a:srgbClr val="0EA5E9"/>
+                </a:solidFill>
+                <a:latin typeface="Consolas"/>
+                <a:cs typeface="Consolas"/>
+              </a:rPr>
+              <a:t>security:scan-logs</a:t>
+            </a:r>
+            <a:r>
+              <a:rPr lang="en-US" sz="1700" dirty="0">
+                <a:solidFill>
+                  <a:srgbClr val="1E293B"/>
+                </a:solidFill>
+              </a:rPr>
+              <a:t> — pindai log akses dan auto-block.</a:t>
+            </a:r>
+          </a:p>
+          <a:p>
+            <a:pPr marL="285750" indent="-285750">
+              <a:buFont typeface="Arial"/>
+              <a:buChar char="•"/>
+            </a:pPr>
+            <a:r>
+              <a:rPr lang="en-US" sz="1600" dirty="0">
+                <a:solidFill>
+                  <a:srgbClr val="0EA5E9"/>
+                </a:solidFill>
+                <a:latin typeface="Consolas"/>
+                <a:cs typeface="Consolas"/>
+              </a:rPr>
+              <a:t>security:baseline</a:t>
+            </a:r>
+            <a:r>
+              <a:rPr lang="en-US" sz="1700" dirty="0">
+                <a:solidFill>
+                  <a:srgbClr val="1E293B"/>
+                </a:solidFill>
+              </a:rPr>
+              <a:t> — audit, buat, atau hapus baseline SHA-256.</a:t>
+            </a:r>
+          </a:p>
+          <a:p>
+            <a:pPr marL="285750" indent="-285750">
+              <a:buFont typeface="Arial"/>
+              <a:buChar char="•"/>
+            </a:pPr>
+            <a:r>
+              <a:rPr lang="en-US" sz="1600" dirty="0">
+                <a:solidFill>
+                  <a:srgbClr val="0EA5E9"/>
+                </a:solidFill>
+                <a:latin typeface="Consolas"/>
+                <a:cs typeface="Consolas"/>
+              </a:rPr>
+              <a:t>security:unblock-ip</a:t>
+            </a:r>
+            <a:r>
+              <a:rPr lang="en-US" sz="1700" dirty="0">
+                <a:solidFill>
+                  <a:srgbClr val="1E293B"/>
+                </a:solidFill>
+              </a:rPr>
+              <a:t> — cabut blokir darurat.</a:t>
+            </a:r>
+          </a:p>
+          <a:p>
+            <a:pPr marL="285750" indent="-285750">
+              <a:buFont typeface="Arial"/>
+              <a:buChar char="•"/>
+            </a:pPr>
+            <a:r>
+              <a:rPr lang="en-US" sz="1600" dirty="0">
+                <a:solidFill>
+                  <a:srgbClr val="0EA5E9"/>
+                </a:solidFill>
+                <a:latin typeface="Consolas"/>
+                <a:cs typeface="Consolas"/>
+              </a:rPr>
+              <a:t>security:prune-logs</a:t>
+            </a:r>
+            <a:r>
+              <a:rPr lang="en-US" sz="1700" dirty="0">
+                <a:solidFill>
+                  <a:srgbClr val="1E293B"/>
+                </a:solidFill>
+              </a:rPr>
+              <a:t> — bersihkan log kedaluwarsa (default 90 hari).</a:t>
+            </a:r>
+          </a:p>
+          <a:p>
+            <a:pPr marL="285750" indent="-285750">
+              <a:buFont typeface="Arial"/>
+              <a:buChar char="•"/>
+            </a:pPr>
+            <a:r>
+              <a:rPr lang="en-US" sz="1600" dirty="0">
+                <a:solidFill>
+                  <a:srgbClr val="0EA5E9"/>
+                </a:solidFill>
+                <a:latin typeface="Consolas"/>
+                <a:cs typeface="Consolas"/>
+              </a:rPr>
+              <a:t>security:purge-injected-data</a:t>
+            </a:r>
+            <a:r>
+              <a:rPr lang="en-US" sz="1700" dirty="0">
+                <a:solidFill>
+                  <a:srgbClr val="1E293B"/>
+                </a:solidFill>
+              </a:rPr>
+              <a:t> — bersihkan residu payload pentest dari database.</a:t>
+            </a:r>
+          </a:p>
+          <a:p>
+            <a:pPr marL="285750" indent="-285750">
+              <a:buFont typeface="Arial"/>
+              <a:buChar char="•"/>
+            </a:pPr>
+            <a:r>
+              <a:rPr lang="en-US" sz="1700" dirty="0">
+                <a:solidFill>
+                  <a:srgbClr val="1E293B"/>
+                </a:solidFill>
+              </a:rPr>
+              <a:t>Scheduler: prune log, heartbeat, dan pemindaian log harian.</a:t>
             </a:r>
           </a:p>
         </p:txBody>
@@ -1425,7 +1526,7 @@
                   <a:srgbClr val="0F172A"/>
                 </a:solidFill>
               </a:rPr>
-              <a:t>CLI Artisan &amp; Automation</a:t>
+              <a:t>Web Server Hardening</a:t>
             </a:r>
           </a:p>
         </p:txBody>
@@ -1487,156 +1588,112 @@
               <a:buChar char="•"/>
             </a:pPr>
             <a:r>
-              <a:rPr lang="en-US" sz="1600" dirty="0">
-                <a:solidFill>
-                  <a:srgbClr val="0EA5E9"/>
-                </a:solidFill>
-                <a:latin typeface="Consolas"/>
-                <a:cs typeface="Consolas"/>
-              </a:rPr>
-              <a:t>security:install</a:t>
-            </a:r>
-            <a:r>
-              <a:rPr lang="en-US" sz="1700" dirty="0">
-                <a:solidFill>
-                  <a:srgbClr val="1E293B"/>
-                </a:solidFill>
-              </a:rPr>
-              <a:t> — publikasi aset + hardening interaktif.</a:t>
-            </a:r>
-          </a:p>
-          <a:p>
-            <a:pPr marL="285750" indent="-285750">
-              <a:buFont typeface="Arial"/>
-              <a:buChar char="•"/>
-            </a:pPr>
-            <a:r>
-              <a:rPr lang="en-US" sz="1600" dirty="0">
-                <a:solidFill>
-                  <a:srgbClr val="0EA5E9"/>
-                </a:solidFill>
-                <a:latin typeface="Consolas"/>
-                <a:cs typeface="Consolas"/>
-              </a:rPr>
-              <a:t>security:scan-logs</a:t>
-            </a:r>
-            <a:r>
-              <a:rPr lang="en-US" sz="1700" dirty="0">
-                <a:solidFill>
-                  <a:srgbClr val="1E293B"/>
-                </a:solidFill>
-              </a:rPr>
-              <a:t> — pindai log akses dan auto-block.</a:t>
-            </a:r>
-          </a:p>
-          <a:p>
-            <a:pPr marL="285750" indent="-285750">
-              <a:buFont typeface="Arial"/>
-              <a:buChar char="•"/>
-            </a:pPr>
-            <a:r>
-              <a:rPr lang="en-US" sz="1600" dirty="0">
-                <a:solidFill>
-                  <a:srgbClr val="0EA5E9"/>
-                </a:solidFill>
-                <a:latin typeface="Consolas"/>
-                <a:cs typeface="Consolas"/>
-              </a:rPr>
-              <a:t>security:baseline</a:t>
-            </a:r>
-            <a:r>
-              <a:rPr lang="en-US" sz="1700" dirty="0">
-                <a:solidFill>
-                  <a:srgbClr val="1E293B"/>
-                </a:solidFill>
-              </a:rPr>
-              <a:t> — audit, buat, atau hapus baseline SHA-256.</a:t>
-            </a:r>
-          </a:p>
-          <a:p>
-            <a:pPr marL="285750" indent="-285750">
-              <a:buFont typeface="Arial"/>
-              <a:buChar char="•"/>
-            </a:pPr>
-            <a:r>
-              <a:rPr lang="en-US" sz="1600" dirty="0">
-                <a:solidFill>
-                  <a:srgbClr val="0EA5E9"/>
-                </a:solidFill>
-                <a:latin typeface="Consolas"/>
-                <a:cs typeface="Consolas"/>
-              </a:rPr>
-              <a:t>security:unblock-ip</a:t>
-            </a:r>
-            <a:r>
-              <a:rPr lang="en-US" sz="1700" dirty="0">
-                <a:solidFill>
-                  <a:srgbClr val="1E293B"/>
-                </a:solidFill>
-              </a:rPr>
-              <a:t> — cabut blokir darurat.</a:t>
-            </a:r>
-          </a:p>
-          <a:p>
-            <a:pPr marL="285750" indent="-285750">
-              <a:buFont typeface="Arial"/>
-              <a:buChar char="•"/>
-            </a:pPr>
-            <a:r>
-              <a:rPr lang="en-US" sz="1600" dirty="0">
-                <a:solidFill>
-                  <a:srgbClr val="0EA5E9"/>
-                </a:solidFill>
-                <a:latin typeface="Consolas"/>
-                <a:cs typeface="Consolas"/>
-              </a:rPr>
-              <a:t>security:prune-logs</a:t>
-            </a:r>
-            <a:r>
-              <a:rPr lang="en-US" sz="1700" dirty="0">
-                <a:solidFill>
-                  <a:srgbClr val="1E293B"/>
-                </a:solidFill>
-              </a:rPr>
-              <a:t> — bersihkan log kedaluwarsa (default 90 hari).</a:t>
-            </a:r>
-          </a:p>
-          <a:p>
-            <a:pPr marL="285750" indent="-285750">
-              <a:buFont typeface="Arial"/>
-              <a:buChar char="•"/>
-            </a:pPr>
-            <a:r>
-              <a:rPr lang="en-US" sz="1600" dirty="0">
-                <a:solidFill>
-                  <a:srgbClr val="0EA5E9"/>
-                </a:solidFill>
-                <a:latin typeface="Consolas"/>
-                <a:cs typeface="Consolas"/>
-              </a:rPr>
-              <a:t>security:purge-injected-data</a:t>
-            </a:r>
-            <a:r>
-              <a:rPr lang="en-US" sz="1700" dirty="0">
-                <a:solidFill>
-                  <a:srgbClr val="1E293B"/>
-                </a:solidFill>
-              </a:rPr>
-              <a:t> — bersihkan residu payload pentest dari database.</a:t>
-            </a:r>
-          </a:p>
-          <a:p>
-            <a:pPr marL="285750" indent="-285750">
-              <a:buFont typeface="Arial"/>
-              <a:buChar char="•"/>
-            </a:pPr>
-            <a:r>
-              <a:rPr lang="en-US" sz="1700" dirty="0">
-                <a:solidFill>
-                  <a:srgbClr val="1E293B"/>
-                </a:solidFill>
-              </a:rPr>
-              <a:t>Scheduler: prune log, heartbeat, dan pemindaian log harian.</a:t>
+              <a:rPr lang="en-US" sz="1700" dirty="0">
+                <a:solidFill>
+                  <a:srgbClr val="1E293B"/>
+                </a:solidFill>
+              </a:rPr>
+              <a:t>Nginx: dual rate-limit zone, eksekusi PHP hanya lewat </a:t>
+            </a:r>
+            <a:r>
+              <a:rPr lang="en-US" sz="1600" dirty="0">
+                <a:solidFill>
+                  <a:srgbClr val="0EA5E9"/>
+                </a:solidFill>
+                <a:latin typeface="Consolas"/>
+                <a:cs typeface="Consolas"/>
+              </a:rPr>
+              <a:t>/index.php</a:t>
+            </a:r>
+            <a:r>
+              <a:rPr lang="en-US" sz="1700" dirty="0">
+                <a:solidFill>
+                  <a:srgbClr val="1E293B"/>
+                </a:solidFill>
+              </a:rPr>
+              <a:t>, sandbox storage, blokir ekstensi ganda.</a:t>
+            </a:r>
+          </a:p>
+          <a:p>
+            <a:pPr marL="285750" indent="-285750">
+              <a:buFont typeface="Arial"/>
+              <a:buChar char="•"/>
+            </a:pPr>
+            <a:r>
+              <a:rPr lang="en-US" sz="1700" dirty="0">
+                <a:solidFill>
+                  <a:srgbClr val="1E293B"/>
+                </a:solidFill>
+              </a:rPr>
+              <a:t>Apache/LiteSpeed: proteksi dotfile, blokir ekstensi ganda, kunci berkas backup/log, matikan directory indexing.</a:t>
+            </a:r>
+          </a:p>
+          <a:p>
+            <a:pPr marL="285750" indent="-285750">
+              <a:buFont typeface="Arial"/>
+              <a:buChar char="•"/>
+            </a:pPr>
+            <a:r>
+              <a:rPr lang="en-US" sz="1700" dirty="0">
+                <a:solidFill>
+                  <a:srgbClr val="1E293B"/>
+                </a:solidFill>
+              </a:rPr>
+              <a:t>Publikasi template: </a:t>
+            </a:r>
+            <a:r>
+              <a:rPr lang="en-US" sz="1600" dirty="0">
+                <a:solidFill>
+                  <a:srgbClr val="0EA5E9"/>
+                </a:solidFill>
+                <a:latin typeface="Consolas"/>
+                <a:cs typeface="Consolas"/>
+              </a:rPr>
+              <a:t>vendor:publish --tag=security-nginx</a:t>
+            </a:r>
+            <a:r>
+              <a:rPr lang="en-US" sz="1700" dirty="0">
+                <a:solidFill>
+                  <a:srgbClr val="1E293B"/>
+                </a:solidFill>
+              </a:rPr>
+              <a:t> / </a:t>
+            </a:r>
+            <a:r>
+              <a:rPr lang="en-US" sz="1600" dirty="0">
+                <a:solidFill>
+                  <a:srgbClr val="0EA5E9"/>
+                </a:solidFill>
+                <a:latin typeface="Consolas"/>
+                <a:cs typeface="Consolas"/>
+              </a:rPr>
+              <a:t>security-htaccess</a:t>
+            </a:r>
+            <a:r>
+              <a:rPr lang="en-US" sz="1700" dirty="0">
+                <a:solidFill>
+                  <a:srgbClr val="1E293B"/>
+                </a:solidFill>
+              </a:rPr>
+              <a:t> / </a:t>
+            </a:r>
+            <a:r>
+              <a:rPr lang="en-US" sz="1600" dirty="0">
+                <a:solidFill>
+                  <a:srgbClr val="0EA5E9"/>
+                </a:solidFill>
+                <a:latin typeface="Consolas"/>
+                <a:cs typeface="Consolas"/>
+              </a:rPr>
+              <a:t>security-all</a:t>
+            </a:r>
+            <a:r>
+              <a:rPr lang="en-US" sz="1700" dirty="0">
+                <a:solidFill>
+                  <a:srgbClr val="1E293B"/>
+                </a:solidFill>
+              </a:rPr>
+              <a:t>.</a:t>
             </a:r>
           </a:p>
         </p:txBody>
@@ -1725,7 +1782,7 @@
                   <a:srgbClr val="0F172A"/>
                 </a:solidFill>
               </a:rPr>
-              <a:t>Web Server Hardening</a:t>
+              <a:t>Instalasi Cepat</a:t>
             </a:r>
           </a:p>
         </p:txBody>
@@ -1787,104 +1844,120 @@
               <a:buChar char="•"/>
             </a:pPr>
             <a:r>
-              <a:rPr lang="en-US" sz="1700" dirty="0">
-                <a:solidFill>
-                  <a:srgbClr val="1E293B"/>
-                </a:solidFill>
-              </a:rPr>
-              <a:t>Nginx: dual rate-limit zone, eksekusi PHP hanya lewat </a:t>
-            </a:r>
-            <a:r>
-              <a:rPr lang="en-US" sz="1600" dirty="0">
-                <a:solidFill>
-                  <a:srgbClr val="0EA5E9"/>
-                </a:solidFill>
-                <a:latin typeface="Consolas"/>
-                <a:cs typeface="Consolas"/>
-              </a:rPr>
-              <a:t>/index.php</a:t>
-            </a:r>
-            <a:r>
-              <a:rPr lang="en-US" sz="1700" dirty="0">
-                <a:solidFill>
-                  <a:srgbClr val="1E293B"/>
-                </a:solidFill>
-              </a:rPr>
-              <a:t>, sandbox storage, blokir ekstensi ganda.</a:t>
-            </a:r>
-          </a:p>
-          <a:p>
-            <a:pPr marL="285750" indent="-285750">
-              <a:buFont typeface="Arial"/>
-              <a:buChar char="•"/>
-            </a:pPr>
-            <a:r>
-              <a:rPr lang="en-US" sz="1700" dirty="0">
-                <a:solidFill>
-                  <a:srgbClr val="1E293B"/>
-                </a:solidFill>
-              </a:rPr>
-              <a:t>Apache/LiteSpeed: proteksi dotfile, blokir ekstensi ganda, kunci berkas backup/log, matikan directory indexing.</a:t>
-            </a:r>
-          </a:p>
-          <a:p>
-            <a:pPr marL="285750" indent="-285750">
-              <a:buFont typeface="Arial"/>
-              <a:buChar char="•"/>
-            </a:pPr>
-            <a:r>
-              <a:rPr lang="en-US" sz="1700" dirty="0">
-                <a:solidFill>
-                  <a:srgbClr val="1E293B"/>
-                </a:solidFill>
-              </a:rPr>
-              <a:t>Publikasi template: </a:t>
-            </a:r>
-            <a:r>
-              <a:rPr lang="en-US" sz="1600" dirty="0">
-                <a:solidFill>
-                  <a:srgbClr val="0EA5E9"/>
-                </a:solidFill>
-                <a:latin typeface="Consolas"/>
-                <a:cs typeface="Consolas"/>
-              </a:rPr>
-              <a:t>vendor:publish --tag=security-nginx</a:t>
-            </a:r>
-            <a:r>
-              <a:rPr lang="en-US" sz="1700" dirty="0">
-                <a:solidFill>
-                  <a:srgbClr val="1E293B"/>
-                </a:solidFill>
-              </a:rPr>
-              <a:t> / </a:t>
-            </a:r>
-            <a:r>
-              <a:rPr lang="en-US" sz="1600" dirty="0">
-                <a:solidFill>
-                  <a:srgbClr val="0EA5E9"/>
-                </a:solidFill>
-                <a:latin typeface="Consolas"/>
-                <a:cs typeface="Consolas"/>
-              </a:rPr>
-              <a:t>security-htaccess</a:t>
-            </a:r>
-            <a:r>
-              <a:rPr lang="en-US" sz="1700" dirty="0">
-                <a:solidFill>
-                  <a:srgbClr val="1E293B"/>
-                </a:solidFill>
-              </a:rPr>
-              <a:t> / </a:t>
-            </a:r>
-            <a:r>
-              <a:rPr lang="en-US" sz="1600" dirty="0">
-                <a:solidFill>
-                  <a:srgbClr val="0EA5E9"/>
-                </a:solidFill>
-                <a:latin typeface="Consolas"/>
-                <a:cs typeface="Consolas"/>
-              </a:rPr>
-              <a:t>security-all</a:t>
+              <a:rPr lang="en-US" sz="1600" dirty="0">
+                <a:solidFill>
+                  <a:srgbClr val="0EA5E9"/>
+                </a:solidFill>
+                <a:latin typeface="Consolas"/>
+                <a:cs typeface="Consolas"/>
+              </a:rPr>
+              <a:t>composer require robyajo/laravel-security-monitor</a:t>
+            </a:r>
+          </a:p>
+          <a:p>
+            <a:pPr marL="285750" indent="-285750">
+              <a:buFont typeface="Arial"/>
+              <a:buChar char="•"/>
+            </a:pPr>
+            <a:r>
+              <a:rPr lang="en-US" sz="1600" dirty="0">
+                <a:solidFill>
+                  <a:srgbClr val="0EA5E9"/>
+                </a:solidFill>
+                <a:latin typeface="Consolas"/>
+                <a:cs typeface="Consolas"/>
+              </a:rPr>
+              <a:t>php artisan security:install</a:t>
+            </a:r>
+          </a:p>
+          <a:p>
+            <a:pPr marL="285750" indent="-285750">
+              <a:buFont typeface="Arial"/>
+              <a:buChar char="•"/>
+            </a:pPr>
+            <a:r>
+              <a:rPr lang="en-US" sz="1600" dirty="0">
+                <a:solidFill>
+                  <a:srgbClr val="0EA5E9"/>
+                </a:solidFill>
+                <a:latin typeface="Consolas"/>
+                <a:cs typeface="Consolas"/>
+              </a:rPr>
+              <a:t>php artisan migrate</a:t>
+            </a:r>
+          </a:p>
+          <a:p>
+            <a:pPr marL="285750" indent="-285750">
+              <a:buFont typeface="Arial"/>
+              <a:buChar char="•"/>
+            </a:pPr>
+            <a:r>
+              <a:rPr lang="en-US" sz="1700" dirty="0">
+                <a:solidFill>
+                  <a:srgbClr val="1E293B"/>
+                </a:solidFill>
+              </a:rPr>
+              <a:t>Tambahkan trait </a:t>
+            </a:r>
+            <a:r>
+              <a:rPr lang="en-US" sz="1600" dirty="0">
+                <a:solidFill>
+                  <a:srgbClr val="0EA5E9"/>
+                </a:solidFill>
+                <a:latin typeface="Consolas"/>
+                <a:cs typeface="Consolas"/>
+              </a:rPr>
+              <a:t>HasSecurityRelations</a:t>
+            </a:r>
+            <a:r>
+              <a:rPr lang="en-US" sz="1700" dirty="0">
+                <a:solidFill>
+                  <a:srgbClr val="1E293B"/>
+                </a:solidFill>
+              </a:rPr>
+              <a:t> ke model </a:t>
+            </a:r>
+            <a:r>
+              <a:rPr lang="en-US" sz="1600" dirty="0">
+                <a:solidFill>
+                  <a:srgbClr val="0EA5E9"/>
+                </a:solidFill>
+                <a:latin typeface="Consolas"/>
+                <a:cs typeface="Consolas"/>
+              </a:rPr>
+              <a:t>User</a:t>
+            </a:r>
+            <a:r>
+              <a:rPr lang="en-US" sz="1700" dirty="0">
+                <a:solidFill>
+                  <a:srgbClr val="1E293B"/>
+                </a:solidFill>
+              </a:rPr>
+              <a:t> dan daftarkan middleware.</a:t>
+            </a:r>
+          </a:p>
+          <a:p>
+            <a:pPr marL="285750" indent="-285750">
+              <a:buFont typeface="Arial"/>
+              <a:buChar char="•"/>
+            </a:pPr>
+            <a:r>
+              <a:rPr lang="en-US" sz="1700" dirty="0">
+                <a:solidFill>
+                  <a:srgbClr val="1E293B"/>
+                </a:solidFill>
+              </a:rPr>
+              <a:t>Opsional: </a:t>
+            </a:r>
+            <a:r>
+              <a:rPr lang="en-US" sz="1600" dirty="0">
+                <a:solidFill>
+                  <a:srgbClr val="0EA5E9"/>
+                </a:solidFill>
+                <a:latin typeface="Consolas"/>
+                <a:cs typeface="Consolas"/>
+              </a:rPr>
+              <a:t>SECURITY_AUTO_REGISTER_MIDDLEWARE=true</a:t>
             </a:r>
             <a:r>
               <a:rPr lang="en-US" sz="1700" dirty="0">
@@ -1893,6 +1966,22 @@
                 </a:solidFill>
               </a:rPr>
               <a:t>.</a:t>
+            </a:r>
+          </a:p>
+          <a:p>
+            <a:pPr marL="285750" indent="-285750">
+              <a:buFont typeface="Arial"/>
+              <a:buChar char="•"/>
+            </a:pPr>
+            <a:r>
+              <a:rPr lang="en-US" sz="1600" dirty="0">
+                <a:solidFill>
+                  <a:srgbClr val="0EA5E9"/>
+                </a:solidFill>
+                <a:latin typeface="Consolas"/>
+                <a:cs typeface="Consolas"/>
+              </a:rPr>
+              <a:t>php artisan security:baseline --create</a:t>
             </a:r>
           </a:p>
         </p:txBody>
@@ -1981,7 +2070,7 @@
                   <a:srgbClr val="0F172A"/>
                 </a:solidFill>
               </a:rPr>
-              <a:t>Instalasi Cepat</a:t>
+              <a:t>Kualitas &amp; Kompatibilitas</a:t>
             </a:r>
           </a:p>
         </p:txBody>
@@ -2043,144 +2132,54 @@
               <a:buChar char="•"/>
             </a:pPr>
             <a:r>
-              <a:rPr lang="en-US" sz="1600" dirty="0">
-                <a:solidFill>
-                  <a:srgbClr val="0EA5E9"/>
-                </a:solidFill>
-                <a:latin typeface="Consolas"/>
-                <a:cs typeface="Consolas"/>
-              </a:rPr>
-              <a:t>composer require robyajo/laravel-security-monitor</a:t>
-            </a:r>
-          </a:p>
-          <a:p>
-            <a:pPr marL="285750" indent="-285750">
-              <a:buFont typeface="Arial"/>
-              <a:buChar char="•"/>
-            </a:pPr>
-            <a:r>
-              <a:rPr lang="en-US" sz="1600" dirty="0">
-                <a:solidFill>
-                  <a:srgbClr val="0EA5E9"/>
-                </a:solidFill>
-                <a:latin typeface="Consolas"/>
-                <a:cs typeface="Consolas"/>
-              </a:rPr>
-              <a:t>php artisan security:install</a:t>
-            </a:r>
-          </a:p>
-          <a:p>
-            <a:pPr marL="285750" indent="-285750">
-              <a:buFont typeface="Arial"/>
-              <a:buChar char="•"/>
-            </a:pPr>
-            <a:r>
-              <a:rPr lang="en-US" sz="1600" dirty="0">
-                <a:solidFill>
-                  <a:srgbClr val="0EA5E9"/>
-                </a:solidFill>
-                <a:latin typeface="Consolas"/>
-                <a:cs typeface="Consolas"/>
-              </a:rPr>
-              <a:t>php artisan migrate</a:t>
-            </a:r>
-          </a:p>
-          <a:p>
-            <a:pPr marL="285750" indent="-285750">
-              <a:buFont typeface="Arial"/>
-              <a:buChar char="•"/>
-            </a:pPr>
-            <a:r>
-              <a:rPr lang="en-US" sz="1700" dirty="0">
-                <a:solidFill>
-                  <a:srgbClr val="1E293B"/>
-                </a:solidFill>
-              </a:rPr>
-              <a:t>Tambahkan trait </a:t>
-            </a:r>
-            <a:r>
-              <a:rPr lang="en-US" sz="1600" dirty="0">
-                <a:solidFill>
-                  <a:srgbClr val="0EA5E9"/>
-                </a:solidFill>
-                <a:latin typeface="Consolas"/>
-                <a:cs typeface="Consolas"/>
-              </a:rPr>
-              <a:t>HasSecurityRelations</a:t>
-            </a:r>
-            <a:r>
-              <a:rPr lang="en-US" sz="1700" dirty="0">
-                <a:solidFill>
-                  <a:srgbClr val="1E293B"/>
-                </a:solidFill>
-              </a:rPr>
-              <a:t> ke model </a:t>
-            </a:r>
-            <a:r>
-              <a:rPr lang="en-US" sz="1600" dirty="0">
-                <a:solidFill>
-                  <a:srgbClr val="0EA5E9"/>
-                </a:solidFill>
-                <a:latin typeface="Consolas"/>
-                <a:cs typeface="Consolas"/>
-              </a:rPr>
-              <a:t>User</a:t>
-            </a:r>
-            <a:r>
-              <a:rPr lang="en-US" sz="1700" dirty="0">
-                <a:solidFill>
-                  <a:srgbClr val="1E293B"/>
-                </a:solidFill>
-              </a:rPr>
-              <a:t> dan daftarkan middleware.</a:t>
-            </a:r>
-          </a:p>
-          <a:p>
-            <a:pPr marL="285750" indent="-285750">
-              <a:buFont typeface="Arial"/>
-              <a:buChar char="•"/>
-            </a:pPr>
-            <a:r>
-              <a:rPr lang="en-US" sz="1700" dirty="0">
-                <a:solidFill>
-                  <a:srgbClr val="1E293B"/>
-                </a:solidFill>
-              </a:rPr>
-              <a:t>Opsional: </a:t>
-            </a:r>
-            <a:r>
-              <a:rPr lang="en-US" sz="1600" dirty="0">
-                <a:solidFill>
-                  <a:srgbClr val="0EA5E9"/>
-                </a:solidFill>
-                <a:latin typeface="Consolas"/>
-                <a:cs typeface="Consolas"/>
-              </a:rPr>
-              <a:t>SECURITY_AUTO_REGISTER_MIDDLEWARE=true</a:t>
-            </a:r>
-            <a:r>
-              <a:rPr lang="en-US" sz="1700" dirty="0">
-                <a:solidFill>
-                  <a:srgbClr val="1E293B"/>
-                </a:solidFill>
-              </a:rPr>
-              <a:t>.</a:t>
-            </a:r>
-          </a:p>
-          <a:p>
-            <a:pPr marL="285750" indent="-285750">
-              <a:buFont typeface="Arial"/>
-              <a:buChar char="•"/>
-            </a:pPr>
-            <a:r>
-              <a:rPr lang="en-US" sz="1600" dirty="0">
-                <a:solidFill>
-                  <a:srgbClr val="0EA5E9"/>
-                </a:solidFill>
-                <a:latin typeface="Consolas"/>
-                <a:cs typeface="Consolas"/>
-              </a:rPr>
-              <a:t>php artisan security:baseline --create</a:t>
+              <a:rPr lang="en-US" sz="1700" dirty="0">
+                <a:solidFill>
+                  <a:srgbClr val="1E293B"/>
+                </a:solidFill>
+              </a:rPr>
+              <a:t>70 tes / 302 assertion (Pest PHP + Orchestra Testbench) — semuanya lulus.</a:t>
+            </a:r>
+          </a:p>
+          <a:p>
+            <a:pPr marL="285750" indent="-285750">
+              <a:buFont typeface="Arial"/>
+              <a:buChar char="•"/>
+            </a:pPr>
+            <a:r>
+              <a:rPr lang="en-US" sz="1700" dirty="0">
+                <a:solidFill>
+                  <a:srgbClr val="1E293B"/>
+                </a:solidFill>
+              </a:rPr>
+              <a:t>Matriks CI: Laravel 10–13 × PHP 8.2–8.5 (12 kombinasi, semuanya hijau).</a:t>
+            </a:r>
+          </a:p>
+          <a:p>
+            <a:pPr marL="285750" indent="-285750">
+              <a:buFont typeface="Arial"/>
+              <a:buChar char="•"/>
+            </a:pPr>
+            <a:r>
+              <a:rPr lang="en-US" sz="1700" dirty="0">
+                <a:solidFill>
+                  <a:srgbClr val="1E293B"/>
+                </a:solidFill>
+              </a:rPr>
+              <a:t>ReDoS-safe: setiap regex diuji terhadap payload 100KB+.</a:t>
+            </a:r>
+          </a:p>
+          <a:p>
+            <a:pPr marL="285750" indent="-285750">
+              <a:buFont typeface="Arial"/>
+              <a:buChar char="•"/>
+            </a:pPr>
+            <a:r>
+              <a:rPr lang="en-US" sz="1700" dirty="0">
+                <a:solidFill>
+                  <a:srgbClr val="1E293B"/>
+                </a:solidFill>
+              </a:rPr>
+              <a:t>Lisensi MIT, tanpa dependensi build frontend.</a:t>
             </a:r>
           </a:p>
         </p:txBody>
@@ -2269,7 +2268,7 @@
                   <a:srgbClr val="0F172A"/>
                 </a:solidFill>
               </a:rPr>
-              <a:t>Kualitas &amp; Kompatibilitas</a:t>
+              <a:t>Roadmap</a:t>
             </a:r>
           </a:p>
         </p:txBody>
@@ -2336,49 +2335,63 @@
                   <a:srgbClr val="1E293B"/>
                 </a:solidFill>
               </a:rPr>
-              <a:t>70 tes / 302 assertion (Pest PHP + Orchestra Testbench) — semuanya lulus.</a:t>
-            </a:r>
-          </a:p>
-          <a:p>
-            <a:pPr marL="285750" indent="-285750">
-              <a:buFont typeface="Arial"/>
-              <a:buChar char="•"/>
-            </a:pPr>
-            <a:r>
-              <a:rPr lang="en-US" sz="1700" dirty="0">
-                <a:solidFill>
-                  <a:srgbClr val="1E293B"/>
-                </a:solidFill>
-              </a:rPr>
-              <a:t>Matriks CI: Laravel 10–13 × PHP 8.2–8.5 (12 kombinasi, semuanya hijau).</a:t>
-            </a:r>
-          </a:p>
-          <a:p>
-            <a:pPr marL="285750" indent="-285750">
-              <a:buFont typeface="Arial"/>
-              <a:buChar char="•"/>
-            </a:pPr>
-            <a:r>
-              <a:rPr lang="en-US" sz="1700" dirty="0">
-                <a:solidFill>
-                  <a:srgbClr val="1E293B"/>
-                </a:solidFill>
-              </a:rPr>
-              <a:t>ReDoS-safe: setiap regex diuji terhadap payload 100KB+.</a:t>
-            </a:r>
-          </a:p>
-          <a:p>
-            <a:pPr marL="285750" indent="-285750">
-              <a:buFont typeface="Arial"/>
-              <a:buChar char="•"/>
-            </a:pPr>
-            <a:r>
-              <a:rPr lang="en-US" sz="1700" dirty="0">
-                <a:solidFill>
-                  <a:srgbClr val="1E293B"/>
-                </a:solidFill>
-              </a:rPr>
-              <a:t>Lisensi MIT, tanpa dependensi build frontend.</a:t>
+              <a:t>View default halaman 403 yang dapat dipublikasikan.</a:t>
+            </a:r>
+          </a:p>
+          <a:p>
+            <a:pPr marL="285750" indent="-285750">
+              <a:buFont typeface="Arial"/>
+              <a:buChar char="•"/>
+            </a:pPr>
+            <a:r>
+              <a:rPr lang="en-US" sz="1700" dirty="0">
+                <a:solidFill>
+                  <a:srgbClr val="1E293B"/>
+                </a:solidFill>
+              </a:rPr>
+              <a:t>Analitik statistik dan dashboard opsional.</a:t>
+            </a:r>
+          </a:p>
+          <a:p>
+            <a:pPr marL="285750" indent="-285750">
+              <a:buFont typeface="Arial"/>
+              <a:buChar char="•"/>
+            </a:pPr>
+            <a:r>
+              <a:rPr lang="en-US" sz="1700" dirty="0">
+                <a:solidFill>
+                  <a:srgbClr val="1E293B"/>
+                </a:solidFill>
+              </a:rPr>
+              <a:t>Integrasi notifikasi tambahan (Slack/Telegram).</a:t>
+            </a:r>
+          </a:p>
+          <a:p>
+            <a:pPr marL="285750" indent="-285750">
+              <a:buFont typeface="Arial"/>
+              <a:buChar char="•"/>
+            </a:pPr>
+            <a:r>
+              <a:rPr lang="en-US" sz="1700" dirty="0">
+                <a:solidFill>
+                  <a:srgbClr val="1E293B"/>
+                </a:solidFill>
+              </a:rPr>
+              <a:t>Dokumentasi berbahasa Inggris.</a:t>
+            </a:r>
+          </a:p>
+          <a:p>
+            <a:pPr marL="285750" indent="-285750">
+              <a:buFont typeface="Arial"/>
+              <a:buChar char="•"/>
+            </a:pPr>
+            <a:r>
+              <a:rPr lang="en-US" sz="1700" dirty="0">
+                <a:solidFill>
+                  <a:srgbClr val="1E293B"/>
+                </a:solidFill>
+              </a:rPr>
+              <a:t>Static analysis (PHPStan/Larastan) di pipeline CI.</a:t>
             </a:r>
           </a:p>
         </p:txBody>
@@ -2410,14 +2423,14 @@
       </p:grpSpPr>
       <p:sp>
         <p:nvSpPr>
-          <p:cNvPr id="2" name="TopBar"/>
+          <p:cNvPr id="2" name="BG"/>
           <p:cNvSpPr/>
           <p:nvPr/>
         </p:nvSpPr>
         <p:spPr>
           <a:xfrm>
             <a:off x="0" y="0"/>
-            <a:ext cx="12192000" cy="182880"/>
+            <a:ext cx="12192000" cy="6858000"/>
           </a:xfrm>
           <a:prstGeom prst="rect">
             <a:avLst/>
@@ -2437,14 +2450,41 @@
       </p:sp>
       <p:sp>
         <p:nvSpPr>
-          <p:cNvPr id="3" name="Title"/>
+          <p:cNvPr id="3" name="Accent"/>
+          <p:cNvSpPr/>
+          <p:nvPr/>
+        </p:nvSpPr>
+        <p:spPr>
+          <a:xfrm>
+            <a:off x="838200" y="3300000"/>
+            <a:ext cx="1600200" cy="45720"/>
+          </a:xfrm>
+          <a:prstGeom prst="rect">
+            <a:avLst/>
+          </a:prstGeom>
+          <a:solidFill>
+            <a:srgbClr val="06B6D4"/>
+          </a:solidFill>
+          <a:ln>
+            <a:noFill/>
+          </a:ln>
+        </p:spPr>
+        <p:txBody>
+          <a:bodyPr/>
+          <a:lstStyle/>
+          <a:p/>
+        </p:txBody>
+      </p:sp>
+      <p:sp>
+        <p:nvSpPr>
+          <p:cNvPr id="4" name="Title"/>
           <p:cNvSpPr txBox="1"/>
           <p:nvPr/>
         </p:nvSpPr>
         <p:spPr>
           <a:xfrm>
-            <a:off x="838200" y="420000"/>
-            <a:ext cx="10000000" cy="900000"/>
+            <a:off x="838200" y="3500000"/>
+            <a:ext cx="10515600" cy="1300000"/>
           </a:xfrm>
           <a:prstGeom prst="rect">
             <a:avLst/>
@@ -2462,135 +2502,12 @@
           <a:p>
             <a:pPr/>
             <a:r>
-              <a:rPr lang="en-US" sz="3200" dirty="0" b="1">
-                <a:solidFill>
-                  <a:srgbClr val="0F172A"/>
-                </a:solidFill>
-              </a:rPr>
-              <a:t>Roadmap</a:t>
-            </a:r>
-          </a:p>
-        </p:txBody>
-      </p:sp>
-      <p:sp>
-        <p:nvSpPr>
-          <p:cNvPr id="4" name="Underline"/>
-          <p:cNvSpPr/>
-          <p:nvPr/>
-        </p:nvSpPr>
-        <p:spPr>
-          <a:xfrm>
-            <a:off x="838200" y="1330000"/>
-            <a:ext cx="685800" cy="27432"/>
-          </a:xfrm>
-          <a:prstGeom prst="rect">
-            <a:avLst/>
-          </a:prstGeom>
-          <a:solidFill>
-            <a:srgbClr val="06B6D4"/>
-          </a:solidFill>
-          <a:ln>
-            <a:noFill/>
-          </a:ln>
-        </p:spPr>
-        <p:txBody>
-          <a:bodyPr/>
-          <a:lstStyle/>
-          <a:p/>
-        </p:txBody>
-      </p:sp>
-      <p:sp>
-        <p:nvSpPr>
-          <p:cNvPr id="5" name="Body"/>
-          <p:cNvSpPr txBox="1"/>
-          <p:nvPr/>
-        </p:nvSpPr>
-        <p:spPr>
-          <a:xfrm>
-            <a:off x="838200" y="1600200"/>
-            <a:ext cx="10515600" cy="4900000"/>
-          </a:xfrm>
-          <a:prstGeom prst="rect">
-            <a:avLst/>
-          </a:prstGeom>
-          <a:noFill/>
-          <a:ln>
-            <a:noFill/>
-          </a:ln>
-        </p:spPr>
-        <p:txBody>
-          <a:bodyPr wrap="square" lIns="0" rIns="0" tIns="0" bIns="0" anchor="t">
-            <a:normAutofit/>
-          </a:bodyPr>
-          <a:lstStyle/>
-          <a:p>
-            <a:pPr marL="285750" indent="-285750">
-              <a:buFont typeface="Arial"/>
-              <a:buChar char="•"/>
-            </a:pPr>
-            <a:r>
-              <a:rPr lang="en-US" sz="1700" dirty="0">
-                <a:solidFill>
-                  <a:srgbClr val="1E293B"/>
-                </a:solidFill>
-              </a:rPr>
-              <a:t>View default halaman 403 yang dapat dipublikasikan.</a:t>
-            </a:r>
-          </a:p>
-          <a:p>
-            <a:pPr marL="285750" indent="-285750">
-              <a:buFont typeface="Arial"/>
-              <a:buChar char="•"/>
-            </a:pPr>
-            <a:r>
-              <a:rPr lang="en-US" sz="1700" dirty="0">
-                <a:solidFill>
-                  <a:srgbClr val="1E293B"/>
-                </a:solidFill>
-              </a:rPr>
-              <a:t>Analitik statistik dan dashboard opsional.</a:t>
-            </a:r>
-          </a:p>
-          <a:p>
-            <a:pPr marL="285750" indent="-285750">
-              <a:buFont typeface="Arial"/>
-              <a:buChar char="•"/>
-            </a:pPr>
-            <a:r>
-              <a:rPr lang="en-US" sz="1700" dirty="0">
-                <a:solidFill>
-                  <a:srgbClr val="1E293B"/>
-                </a:solidFill>
-              </a:rPr>
-              <a:t>Integrasi notifikasi tambahan (Slack/Telegram).</a:t>
-            </a:r>
-          </a:p>
-          <a:p>
-            <a:pPr marL="285750" indent="-285750">
-              <a:buFont typeface="Arial"/>
-              <a:buChar char="•"/>
-            </a:pPr>
-            <a:r>
-              <a:rPr lang="en-US" sz="1700" dirty="0">
-                <a:solidFill>
-                  <a:srgbClr val="1E293B"/>
-                </a:solidFill>
-              </a:rPr>
-              <a:t>Dokumentasi berbahasa Inggris.</a:t>
-            </a:r>
-          </a:p>
-          <a:p>
-            <a:pPr marL="285750" indent="-285750">
-              <a:buFont typeface="Arial"/>
-              <a:buChar char="•"/>
-            </a:pPr>
-            <a:r>
-              <a:rPr lang="en-US" sz="1700" dirty="0">
-                <a:solidFill>
-                  <a:srgbClr val="1E293B"/>
-                </a:solidFill>
-              </a:rPr>
-              <a:t>Static analysis (PHPStan/Larastan) di pipeline CI.</a:t>
+              <a:rPr lang="en-US" sz="4000" dirty="0" b="1">
+                <a:solidFill>
+                  <a:srgbClr val="FFFFFF"/>
+                </a:solidFill>
+              </a:rPr>
+              <a:t>Terima Kasih</a:t>
             </a:r>
           </a:p>
         </p:txBody>
@@ -2622,14 +2539,14 @@
       </p:grpSpPr>
       <p:sp>
         <p:nvSpPr>
-          <p:cNvPr id="2" name="BG"/>
+          <p:cNvPr id="2" name="TopBar"/>
           <p:cNvSpPr/>
           <p:nvPr/>
         </p:nvSpPr>
         <p:spPr>
           <a:xfrm>
             <a:off x="0" y="0"/>
-            <a:ext cx="12192000" cy="6858000"/>
+            <a:ext cx="12192000" cy="182880"/>
           </a:xfrm>
           <a:prstGeom prst="rect">
             <a:avLst/>
@@ -2649,14 +2566,51 @@
       </p:sp>
       <p:sp>
         <p:nvSpPr>
-          <p:cNvPr id="3" name="Accent"/>
+          <p:cNvPr id="3" name="Title"/>
+          <p:cNvSpPr txBox="1"/>
+          <p:nvPr/>
+        </p:nvSpPr>
+        <p:spPr>
+          <a:xfrm>
+            <a:off x="838200" y="420000"/>
+            <a:ext cx="10000000" cy="900000"/>
+          </a:xfrm>
+          <a:prstGeom prst="rect">
+            <a:avLst/>
+          </a:prstGeom>
+          <a:noFill/>
+          <a:ln>
+            <a:noFill/>
+          </a:ln>
+        </p:spPr>
+        <p:txBody>
+          <a:bodyPr wrap="square" lIns="0" rIns="0" tIns="0" bIns="0" anchor="t">
+            <a:normAutofit/>
+          </a:bodyPr>
+          <a:lstStyle/>
+          <a:p>
+            <a:pPr/>
+            <a:r>
+              <a:rPr lang="en-US" sz="3200" dirty="0" b="1">
+                <a:solidFill>
+                  <a:srgbClr val="0F172A"/>
+                </a:solidFill>
+              </a:rPr>
+              <a:t>Tautan</a:t>
+            </a:r>
+          </a:p>
+        </p:txBody>
+      </p:sp>
+      <p:sp>
+        <p:nvSpPr>
+          <p:cNvPr id="4" name="Underline"/>
           <p:cNvSpPr/>
           <p:nvPr/>
         </p:nvSpPr>
         <p:spPr>
           <a:xfrm>
-            <a:off x="838200" y="3300000"/>
-            <a:ext cx="1600200" cy="45720"/>
+            <a:off x="838200" y="1330000"/>
+            <a:ext cx="685800" cy="27432"/>
           </a:xfrm>
           <a:prstGeom prst="rect">
             <a:avLst/>
@@ -2676,14 +2630,14 @@
       </p:sp>
       <p:sp>
         <p:nvSpPr>
-          <p:cNvPr id="4" name="Title"/>
+          <p:cNvPr id="5" name="Body"/>
           <p:cNvSpPr txBox="1"/>
           <p:nvPr/>
         </p:nvSpPr>
         <p:spPr>
           <a:xfrm>
-            <a:off x="838200" y="3500000"/>
-            <a:ext cx="10515600" cy="1300000"/>
+            <a:off x="838200" y="1600200"/>
+            <a:ext cx="10515600" cy="4900000"/>
           </a:xfrm>
           <a:prstGeom prst="rect">
             <a:avLst/>
@@ -2699,14 +2653,117 @@
           </a:bodyPr>
           <a:lstStyle/>
           <a:p>
-            <a:pPr/>
-            <a:r>
-              <a:rPr lang="en-US" sz="4000" dirty="0" b="1">
-                <a:solidFill>
-                  <a:srgbClr val="FFFFFF"/>
-                </a:solidFill>
-              </a:rPr>
-              <a:t>Terima Kasih</a:t>
+            <a:pPr marL="285750" indent="-285750">
+              <a:buFont typeface="Arial"/>
+              <a:buChar char="•"/>
+            </a:pPr>
+            <a:r>
+              <a:rPr lang="en-US" sz="1700" dirty="0">
+                <a:solidFill>
+                  <a:srgbClr val="1E293B"/>
+                </a:solidFill>
+              </a:rPr>
+              <a:t>Repositori: </a:t>
+            </a:r>
+            <a:r>
+              <a:rPr lang="en-US" sz="1600" dirty="0">
+                <a:solidFill>
+                  <a:srgbClr val="0EA5E9"/>
+                </a:solidFill>
+                <a:latin typeface="Consolas"/>
+                <a:cs typeface="Consolas"/>
+              </a:rPr>
+              <a:t>github.com/robyajo/laravel-security-monitor</a:t>
+            </a:r>
+          </a:p>
+          <a:p>
+            <a:pPr marL="285750" indent="-285750">
+              <a:buFont typeface="Arial"/>
+              <a:buChar char="•"/>
+            </a:pPr>
+            <a:r>
+              <a:rPr lang="en-US" sz="1700" dirty="0">
+                <a:solidFill>
+                  <a:srgbClr val="1E293B"/>
+                </a:solidFill>
+              </a:rPr>
+              <a:t>Packagist: </a:t>
+            </a:r>
+            <a:r>
+              <a:rPr lang="en-US" sz="1600" dirty="0">
+                <a:solidFill>
+                  <a:srgbClr val="0EA5E9"/>
+                </a:solidFill>
+                <a:latin typeface="Consolas"/>
+                <a:cs typeface="Consolas"/>
+              </a:rPr>
+              <a:t>packagist.org/packages/robyajo/laravel-security-monitor</a:t>
+            </a:r>
+          </a:p>
+          <a:p>
+            <a:pPr marL="285750" indent="-285750">
+              <a:buFont typeface="Arial"/>
+              <a:buChar char="•"/>
+            </a:pPr>
+            <a:r>
+              <a:rPr lang="en-US" sz="1700" dirty="0">
+                <a:solidFill>
+                  <a:srgbClr val="1E293B"/>
+                </a:solidFill>
+              </a:rPr>
+              <a:t>Instalasi: </a:t>
+            </a:r>
+            <a:r>
+              <a:rPr lang="en-US" sz="1600" dirty="0">
+                <a:solidFill>
+                  <a:srgbClr val="0EA5E9"/>
+                </a:solidFill>
+                <a:latin typeface="Consolas"/>
+                <a:cs typeface="Consolas"/>
+              </a:rPr>
+              <a:t>composer require robyajo/laravel-security-monitor</a:t>
+            </a:r>
+          </a:p>
+          <a:p>
+            <a:pPr marL="285750" indent="-285750">
+              <a:buFont typeface="Arial"/>
+              <a:buChar char="•"/>
+            </a:pPr>
+            <a:r>
+              <a:rPr lang="en-US" sz="1700" dirty="0">
+                <a:solidFill>
+                  <a:srgbClr val="1E293B"/>
+                </a:solidFill>
+              </a:rPr>
+              <a:t>Dokumentasi: direktori </a:t>
+            </a:r>
+            <a:r>
+              <a:rPr lang="en-US" sz="1600" dirty="0">
+                <a:solidFill>
+                  <a:srgbClr val="0EA5E9"/>
+                </a:solidFill>
+                <a:latin typeface="Consolas"/>
+                <a:cs typeface="Consolas"/>
+              </a:rPr>
+              <a:t>documents/</a:t>
+            </a:r>
+            <a:r>
+              <a:rPr lang="en-US" sz="1700" dirty="0">
+                <a:solidFill>
+                  <a:srgbClr val="1E293B"/>
+                </a:solidFill>
+              </a:rPr>
+              <a:t> (25 bab) + portal </a:t>
+            </a:r>
+            <a:r>
+              <a:rPr lang="en-US" sz="1600" dirty="0">
+                <a:solidFill>
+                  <a:srgbClr val="0EA5E9"/>
+                </a:solidFill>
+                <a:latin typeface="Consolas"/>
+                <a:cs typeface="Consolas"/>
+              </a:rPr>
+              <a:t>documents/index.html</a:t>
             </a:r>
           </a:p>
         </p:txBody>
@@ -2917,262 +2974,6 @@
 </p:sld>
 </file>
 
-<file path=ppt/slides/slide20.xml><?xml version="1.0" encoding="utf-8"?>
-<p:sld xmlns:a="http://schemas.openxmlformats.org/drawingml/2006/main" xmlns:r="http://schemas.openxmlformats.org/officeDocument/2006/relationships" xmlns:p="http://schemas.openxmlformats.org/presentationml/2006/main">
-  <p:cSld>
-    <p:spTree>
-      <p:nvGrpSpPr>
-        <p:cNvPr id="1" name=""/>
-        <p:cNvGrpSpPr/>
-        <p:nvPr/>
-      </p:nvGrpSpPr>
-      <p:grpSpPr>
-        <a:xfrm>
-          <a:off x="0" y="0"/>
-          <a:ext cx="0" cy="0"/>
-          <a:chOff x="0" y="0"/>
-          <a:chExt cx="0" cy="0"/>
-        </a:xfrm>
-      </p:grpSpPr>
-      <p:sp>
-        <p:nvSpPr>
-          <p:cNvPr id="2" name="TopBar"/>
-          <p:cNvSpPr/>
-          <p:nvPr/>
-        </p:nvSpPr>
-        <p:spPr>
-          <a:xfrm>
-            <a:off x="0" y="0"/>
-            <a:ext cx="12192000" cy="182880"/>
-          </a:xfrm>
-          <a:prstGeom prst="rect">
-            <a:avLst/>
-          </a:prstGeom>
-          <a:solidFill>
-            <a:srgbClr val="0F172A"/>
-          </a:solidFill>
-          <a:ln>
-            <a:noFill/>
-          </a:ln>
-        </p:spPr>
-        <p:txBody>
-          <a:bodyPr/>
-          <a:lstStyle/>
-          <a:p/>
-        </p:txBody>
-      </p:sp>
-      <p:sp>
-        <p:nvSpPr>
-          <p:cNvPr id="3" name="Title"/>
-          <p:cNvSpPr txBox="1"/>
-          <p:nvPr/>
-        </p:nvSpPr>
-        <p:spPr>
-          <a:xfrm>
-            <a:off x="838200" y="420000"/>
-            <a:ext cx="10000000" cy="900000"/>
-          </a:xfrm>
-          <a:prstGeom prst="rect">
-            <a:avLst/>
-          </a:prstGeom>
-          <a:noFill/>
-          <a:ln>
-            <a:noFill/>
-          </a:ln>
-        </p:spPr>
-        <p:txBody>
-          <a:bodyPr wrap="square" lIns="0" rIns="0" tIns="0" bIns="0" anchor="t">
-            <a:normAutofit/>
-          </a:bodyPr>
-          <a:lstStyle/>
-          <a:p>
-            <a:pPr/>
-            <a:r>
-              <a:rPr lang="en-US" sz="3200" dirty="0" b="1">
-                <a:solidFill>
-                  <a:srgbClr val="0F172A"/>
-                </a:solidFill>
-              </a:rPr>
-              <a:t>Tautan</a:t>
-            </a:r>
-          </a:p>
-        </p:txBody>
-      </p:sp>
-      <p:sp>
-        <p:nvSpPr>
-          <p:cNvPr id="4" name="Underline"/>
-          <p:cNvSpPr/>
-          <p:nvPr/>
-        </p:nvSpPr>
-        <p:spPr>
-          <a:xfrm>
-            <a:off x="838200" y="1330000"/>
-            <a:ext cx="685800" cy="27432"/>
-          </a:xfrm>
-          <a:prstGeom prst="rect">
-            <a:avLst/>
-          </a:prstGeom>
-          <a:solidFill>
-            <a:srgbClr val="06B6D4"/>
-          </a:solidFill>
-          <a:ln>
-            <a:noFill/>
-          </a:ln>
-        </p:spPr>
-        <p:txBody>
-          <a:bodyPr/>
-          <a:lstStyle/>
-          <a:p/>
-        </p:txBody>
-      </p:sp>
-      <p:sp>
-        <p:nvSpPr>
-          <p:cNvPr id="5" name="Body"/>
-          <p:cNvSpPr txBox="1"/>
-          <p:nvPr/>
-        </p:nvSpPr>
-        <p:spPr>
-          <a:xfrm>
-            <a:off x="838200" y="1600200"/>
-            <a:ext cx="10515600" cy="4900000"/>
-          </a:xfrm>
-          <a:prstGeom prst="rect">
-            <a:avLst/>
-          </a:prstGeom>
-          <a:noFill/>
-          <a:ln>
-            <a:noFill/>
-          </a:ln>
-        </p:spPr>
-        <p:txBody>
-          <a:bodyPr wrap="square" lIns="0" rIns="0" tIns="0" bIns="0" anchor="t">
-            <a:normAutofit/>
-          </a:bodyPr>
-          <a:lstStyle/>
-          <a:p>
-            <a:pPr marL="285750" indent="-285750">
-              <a:buFont typeface="Arial"/>
-              <a:buChar char="•"/>
-            </a:pPr>
-            <a:r>
-              <a:rPr lang="en-US" sz="1700" dirty="0">
-                <a:solidFill>
-                  <a:srgbClr val="1E293B"/>
-                </a:solidFill>
-              </a:rPr>
-              <a:t>Repositori: </a:t>
-            </a:r>
-            <a:r>
-              <a:rPr lang="en-US" sz="1600" dirty="0">
-                <a:solidFill>
-                  <a:srgbClr val="0EA5E9"/>
-                </a:solidFill>
-                <a:latin typeface="Consolas"/>
-                <a:cs typeface="Consolas"/>
-              </a:rPr>
-              <a:t>github.com/robyajo/laravel-security-monitor</a:t>
-            </a:r>
-          </a:p>
-          <a:p>
-            <a:pPr marL="285750" indent="-285750">
-              <a:buFont typeface="Arial"/>
-              <a:buChar char="•"/>
-            </a:pPr>
-            <a:r>
-              <a:rPr lang="en-US" sz="1700" dirty="0">
-                <a:solidFill>
-                  <a:srgbClr val="1E293B"/>
-                </a:solidFill>
-              </a:rPr>
-              <a:t>Packagist: </a:t>
-            </a:r>
-            <a:r>
-              <a:rPr lang="en-US" sz="1600" dirty="0">
-                <a:solidFill>
-                  <a:srgbClr val="0EA5E9"/>
-                </a:solidFill>
-                <a:latin typeface="Consolas"/>
-                <a:cs typeface="Consolas"/>
-              </a:rPr>
-              <a:t>packagist.org/packages/robyajo/laravel-security-monitor</a:t>
-            </a:r>
-          </a:p>
-          <a:p>
-            <a:pPr marL="285750" indent="-285750">
-              <a:buFont typeface="Arial"/>
-              <a:buChar char="•"/>
-            </a:pPr>
-            <a:r>
-              <a:rPr lang="en-US" sz="1700" dirty="0">
-                <a:solidFill>
-                  <a:srgbClr val="1E293B"/>
-                </a:solidFill>
-              </a:rPr>
-              <a:t>Instalasi: </a:t>
-            </a:r>
-            <a:r>
-              <a:rPr lang="en-US" sz="1600" dirty="0">
-                <a:solidFill>
-                  <a:srgbClr val="0EA5E9"/>
-                </a:solidFill>
-                <a:latin typeface="Consolas"/>
-                <a:cs typeface="Consolas"/>
-              </a:rPr>
-              <a:t>composer require robyajo/laravel-security-monitor</a:t>
-            </a:r>
-          </a:p>
-          <a:p>
-            <a:pPr marL="285750" indent="-285750">
-              <a:buFont typeface="Arial"/>
-              <a:buChar char="•"/>
-            </a:pPr>
-            <a:r>
-              <a:rPr lang="en-US" sz="1700" dirty="0">
-                <a:solidFill>
-                  <a:srgbClr val="1E293B"/>
-                </a:solidFill>
-              </a:rPr>
-              <a:t>Dokumentasi: direktori </a:t>
-            </a:r>
-            <a:r>
-              <a:rPr lang="en-US" sz="1600" dirty="0">
-                <a:solidFill>
-                  <a:srgbClr val="0EA5E9"/>
-                </a:solidFill>
-                <a:latin typeface="Consolas"/>
-                <a:cs typeface="Consolas"/>
-              </a:rPr>
-              <a:t>documents/</a:t>
-            </a:r>
-            <a:r>
-              <a:rPr lang="en-US" sz="1700" dirty="0">
-                <a:solidFill>
-                  <a:srgbClr val="1E293B"/>
-                </a:solidFill>
-              </a:rPr>
-              <a:t> (25 bab) + portal </a:t>
-            </a:r>
-            <a:r>
-              <a:rPr lang="en-US" sz="1600" dirty="0">
-                <a:solidFill>
-                  <a:srgbClr val="0EA5E9"/>
-                </a:solidFill>
-                <a:latin typeface="Consolas"/>
-                <a:cs typeface="Consolas"/>
-              </a:rPr>
-              <a:t>documents/index.html</a:t>
-            </a:r>
-          </a:p>
-        </p:txBody>
-      </p:sp>
-    </p:spTree>
-  </p:cSld>
-  <p:clrMapOvr>
-    <a:masterClrMapping/>
-  </p:clrMapOvr>
-</p:sld>
-</file>
-
 <file path=ppt/slides/slide3.xml><?xml version="1.0" encoding="utf-8"?>
 <p:sld xmlns:a="http://schemas.openxmlformats.org/drawingml/2006/main" xmlns:r="http://schemas.openxmlformats.org/officeDocument/2006/relationships" xmlns:p="http://schemas.openxmlformats.org/presentationml/2006/main">
   <p:cSld>
@@ -3588,20 +3389,6 @@
                   <a:srgbClr val="1E293B"/>
                 </a:solidFill>
               </a:rPr>
-              <a:t>Pure SVG CAPTCHA (tanpa GD/Imagick)</a:t>
-            </a:r>
-          </a:p>
-          <a:p>
-            <a:pPr marL="285750" indent="-285750">
-              <a:buFont typeface="Arial"/>
-              <a:buChar char="•"/>
-            </a:pPr>
-            <a:r>
-              <a:rPr lang="en-US" sz="1700" dirty="0">
-                <a:solidFill>
-                  <a:srgbClr val="1E293B"/>
-                </a:solidFill>
-              </a:rPr>
               <a:t>Server Integrity &amp; Webshell Scanner</a:t>
             </a:r>
           </a:p>
@@ -4557,7 +4344,7 @@
                   <a:srgbClr val="0F172A"/>
                 </a:solidFill>
               </a:rPr>
-              <a:t>Pure SVG CAPTCHA Tanpa Dependensi</a:t>
+              <a:t>Server Integrity &amp; Webshell Scanner</a:t>
             </a:r>
           </a:p>
         </p:txBody>
@@ -4624,85 +4411,185 @@
                   <a:srgbClr val="1E293B"/>
                 </a:solidFill>
               </a:rPr>
-              <a:t>Dibuat murni dengan matematika vektor PHP — tanpa </a:t>
-            </a:r>
-            <a:r>
-              <a:rPr lang="en-US" sz="1600" dirty="0">
-                <a:solidFill>
-                  <a:srgbClr val="0EA5E9"/>
-                </a:solidFill>
-                <a:latin typeface="Consolas"/>
-                <a:cs typeface="Consolas"/>
-              </a:rPr>
-              <a:t>ext-gd</a:t>
-            </a:r>
-            <a:r>
-              <a:rPr lang="en-US" sz="1700" dirty="0">
-                <a:solidFill>
-                  <a:srgbClr val="1E293B"/>
-                </a:solidFill>
-              </a:rPr>
-              <a:t>, tanpa Imagick, tanpa library npm.</a:t>
-            </a:r>
-          </a:p>
-          <a:p>
-            <a:pPr marL="285750" indent="-285750">
-              <a:buFont typeface="Arial"/>
-              <a:buChar char="•"/>
-            </a:pPr>
-            <a:r>
-              <a:rPr lang="en-US" sz="1700" dirty="0">
-                <a:solidFill>
-                  <a:srgbClr val="1E293B"/>
-                </a:solidFill>
-              </a:rPr>
-              <a:t>Distorsi anti-OCR pada setiap tantangan.</a:t>
-            </a:r>
-          </a:p>
-          <a:p>
-            <a:pPr marL="285750" indent="-285750">
-              <a:buFont typeface="Arial"/>
-              <a:buChar char="•"/>
-            </a:pPr>
-            <a:r>
-              <a:rPr lang="en-US" sz="1700" dirty="0">
-                <a:solidFill>
-                  <a:srgbClr val="1E293B"/>
-                </a:solidFill>
-              </a:rPr>
-              <a:t>Token sekali pakai dengan verifikasi stateless.</a:t>
-            </a:r>
-          </a:p>
-          <a:p>
-            <a:pPr marL="285750" indent="-285750">
-              <a:buFont typeface="Arial"/>
-              <a:buChar char="•"/>
-            </a:pPr>
-            <a:r>
-              <a:rPr lang="en-US" sz="1700" dirty="0">
-                <a:solidFill>
-                  <a:srgbClr val="1E293B"/>
-                </a:solidFill>
-              </a:rPr>
-              <a:t>Validation Rule </a:t>
-            </a:r>
-            <a:r>
-              <a:rPr lang="en-US" sz="1600" dirty="0">
-                <a:solidFill>
-                  <a:srgbClr val="0EA5E9"/>
-                </a:solidFill>
-                <a:latin typeface="Consolas"/>
-                <a:cs typeface="Consolas"/>
-              </a:rPr>
-              <a:t>ValidCaptcha</a:t>
-            </a:r>
-            <a:r>
-              <a:rPr lang="en-US" sz="1700" dirty="0">
-                <a:solidFill>
-                  <a:srgbClr val="1E293B"/>
-                </a:solidFill>
-              </a:rPr>
-              <a:t> siap dipakai di form mana pun.</a:t>
+              <a:t>Baseline integritas SHA-256 untuk berkas inti (</a:t>
+            </a:r>
+            <a:r>
+              <a:rPr lang="en-US" sz="1600" dirty="0">
+                <a:solidFill>
+                  <a:srgbClr val="0EA5E9"/>
+                </a:solidFill>
+                <a:latin typeface="Consolas"/>
+                <a:cs typeface="Consolas"/>
+              </a:rPr>
+              <a:t>app/</a:t>
+            </a:r>
+            <a:r>
+              <a:rPr lang="en-US" sz="1700" dirty="0">
+                <a:solidFill>
+                  <a:srgbClr val="1E293B"/>
+                </a:solidFill>
+              </a:rPr>
+              <a:t>, </a:t>
+            </a:r>
+            <a:r>
+              <a:rPr lang="en-US" sz="1600" dirty="0">
+                <a:solidFill>
+                  <a:srgbClr val="0EA5E9"/>
+                </a:solidFill>
+                <a:latin typeface="Consolas"/>
+                <a:cs typeface="Consolas"/>
+              </a:rPr>
+              <a:t>config/</a:t>
+            </a:r>
+            <a:r>
+              <a:rPr lang="en-US" sz="1700" dirty="0">
+                <a:solidFill>
+                  <a:srgbClr val="1E293B"/>
+                </a:solidFill>
+              </a:rPr>
+              <a:t>, </a:t>
+            </a:r>
+            <a:r>
+              <a:rPr lang="en-US" sz="1600" dirty="0">
+                <a:solidFill>
+                  <a:srgbClr val="0EA5E9"/>
+                </a:solidFill>
+                <a:latin typeface="Consolas"/>
+                <a:cs typeface="Consolas"/>
+              </a:rPr>
+              <a:t>routes/</a:t>
+            </a:r>
+            <a:r>
+              <a:rPr lang="en-US" sz="1700" dirty="0">
+                <a:solidFill>
+                  <a:srgbClr val="1E293B"/>
+                </a:solidFill>
+              </a:rPr>
+              <a:t>, </a:t>
+            </a:r>
+            <a:r>
+              <a:rPr lang="en-US" sz="1600" dirty="0">
+                <a:solidFill>
+                  <a:srgbClr val="0EA5E9"/>
+                </a:solidFill>
+                <a:latin typeface="Consolas"/>
+                <a:cs typeface="Consolas"/>
+              </a:rPr>
+              <a:t>public/index.php</a:t>
+            </a:r>
+            <a:r>
+              <a:rPr lang="en-US" sz="1700" dirty="0">
+                <a:solidFill>
+                  <a:srgbClr val="1E293B"/>
+                </a:solidFill>
+              </a:rPr>
+              <a:t>).</a:t>
+            </a:r>
+          </a:p>
+          <a:p>
+            <a:pPr marL="285750" indent="-285750">
+              <a:buFont typeface="Arial"/>
+              <a:buChar char="•"/>
+            </a:pPr>
+            <a:r>
+              <a:rPr lang="en-US" sz="1700" dirty="0">
+                <a:solidFill>
+                  <a:srgbClr val="1E293B"/>
+                </a:solidFill>
+              </a:rPr>
+              <a:t>Melaporkan berkas yang berubah, hilang, dan berkas baru yang mencurigakan.</a:t>
+            </a:r>
+          </a:p>
+          <a:p>
+            <a:pPr marL="285750" indent="-285750">
+              <a:buFont typeface="Arial"/>
+              <a:buChar char="•"/>
+            </a:pPr>
+            <a:r>
+              <a:rPr lang="en-US" sz="1700" dirty="0">
+                <a:solidFill>
+                  <a:srgbClr val="1E293B"/>
+                </a:solidFill>
+              </a:rPr>
+              <a:t>Pemindai webshell di </a:t>
+            </a:r>
+            <a:r>
+              <a:rPr lang="en-US" sz="1600" dirty="0">
+                <a:solidFill>
+                  <a:srgbClr val="0EA5E9"/>
+                </a:solidFill>
+                <a:latin typeface="Consolas"/>
+                <a:cs typeface="Consolas"/>
+              </a:rPr>
+              <a:t>public/</a:t>
+            </a:r>
+            <a:r>
+              <a:rPr lang="en-US" sz="1700" dirty="0">
+                <a:solidFill>
+                  <a:srgbClr val="1E293B"/>
+                </a:solidFill>
+              </a:rPr>
+              <a:t> &amp; </a:t>
+            </a:r>
+            <a:r>
+              <a:rPr lang="en-US" sz="1600" dirty="0">
+                <a:solidFill>
+                  <a:srgbClr val="0EA5E9"/>
+                </a:solidFill>
+                <a:latin typeface="Consolas"/>
+                <a:cs typeface="Consolas"/>
+              </a:rPr>
+              <a:t>storage/</a:t>
+            </a:r>
+            <a:r>
+              <a:rPr lang="en-US" sz="1700" dirty="0">
+                <a:solidFill>
+                  <a:srgbClr val="1E293B"/>
+                </a:solidFill>
+              </a:rPr>
+              <a:t> (b374k, c99, r57, wso, </a:t>
+            </a:r>
+            <a:r>
+              <a:rPr lang="en-US" sz="1600" dirty="0">
+                <a:solidFill>
+                  <a:srgbClr val="0EA5E9"/>
+                </a:solidFill>
+                <a:latin typeface="Consolas"/>
+                <a:cs typeface="Consolas"/>
+              </a:rPr>
+              <a:t>eval(base64_decode()).</a:t>
+            </a:r>
+          </a:p>
+          <a:p>
+            <a:pPr marL="285750" indent="-285750">
+              <a:buFont typeface="Arial"/>
+              <a:buChar char="•"/>
+            </a:pPr>
+            <a:r>
+              <a:rPr lang="en-US" sz="1700" dirty="0">
+                <a:solidFill>
+                  <a:srgbClr val="1E293B"/>
+                </a:solidFill>
+              </a:rPr>
+              <a:t>Penghapusan aman: anti path-traversal, dibatasi </a:t>
+            </a:r>
+            <a:r>
+              <a:rPr lang="en-US" sz="1600" dirty="0">
+                <a:solidFill>
+                  <a:srgbClr val="0EA5E9"/>
+                </a:solidFill>
+                <a:latin typeface="Consolas"/>
+                <a:cs typeface="Consolas"/>
+              </a:rPr>
+              <a:t>base_path()</a:t>
+            </a:r>
+            <a:r>
+              <a:rPr lang="en-US" sz="1700" dirty="0">
+                <a:solidFill>
+                  <a:srgbClr val="1E293B"/>
+                </a:solidFill>
+              </a:rPr>
+              <a:t>, berkas vital dilindungi.</a:t>
             </a:r>
           </a:p>
         </p:txBody>
@@ -4791,7 +4678,7 @@
                   <a:srgbClr val="0F172A"/>
                 </a:solidFill>
               </a:rPr>
-              <a:t>Server Integrity &amp; Webshell Scanner</a:t>
+              <a:t>Streaming Access Log Scanner</a:t>
             </a:r>
           </a:p>
         </p:txBody>
@@ -4858,185 +4745,49 @@
                   <a:srgbClr val="1E293B"/>
                 </a:solidFill>
               </a:rPr>
-              <a:t>Baseline integritas SHA-256 untuk berkas inti (</a:t>
-            </a:r>
-            <a:r>
-              <a:rPr lang="en-US" sz="1600" dirty="0">
-                <a:solidFill>
-                  <a:srgbClr val="0EA5E9"/>
-                </a:solidFill>
-                <a:latin typeface="Consolas"/>
-                <a:cs typeface="Consolas"/>
-              </a:rPr>
-              <a:t>app/</a:t>
-            </a:r>
-            <a:r>
-              <a:rPr lang="en-US" sz="1700" dirty="0">
-                <a:solidFill>
-                  <a:srgbClr val="1E293B"/>
-                </a:solidFill>
-              </a:rPr>
-              <a:t>, </a:t>
-            </a:r>
-            <a:r>
-              <a:rPr lang="en-US" sz="1600" dirty="0">
-                <a:solidFill>
-                  <a:srgbClr val="0EA5E9"/>
-                </a:solidFill>
-                <a:latin typeface="Consolas"/>
-                <a:cs typeface="Consolas"/>
-              </a:rPr>
-              <a:t>config/</a:t>
-            </a:r>
-            <a:r>
-              <a:rPr lang="en-US" sz="1700" dirty="0">
-                <a:solidFill>
-                  <a:srgbClr val="1E293B"/>
-                </a:solidFill>
-              </a:rPr>
-              <a:t>, </a:t>
-            </a:r>
-            <a:r>
-              <a:rPr lang="en-US" sz="1600" dirty="0">
-                <a:solidFill>
-                  <a:srgbClr val="0EA5E9"/>
-                </a:solidFill>
-                <a:latin typeface="Consolas"/>
-                <a:cs typeface="Consolas"/>
-              </a:rPr>
-              <a:t>routes/</a:t>
-            </a:r>
-            <a:r>
-              <a:rPr lang="en-US" sz="1700" dirty="0">
-                <a:solidFill>
-                  <a:srgbClr val="1E293B"/>
-                </a:solidFill>
-              </a:rPr>
-              <a:t>, </a:t>
-            </a:r>
-            <a:r>
-              <a:rPr lang="en-US" sz="1600" dirty="0">
-                <a:solidFill>
-                  <a:srgbClr val="0EA5E9"/>
-                </a:solidFill>
-                <a:latin typeface="Consolas"/>
-                <a:cs typeface="Consolas"/>
-              </a:rPr>
-              <a:t>public/index.php</a:t>
-            </a:r>
-            <a:r>
-              <a:rPr lang="en-US" sz="1700" dirty="0">
-                <a:solidFill>
-                  <a:srgbClr val="1E293B"/>
-                </a:solidFill>
-              </a:rPr>
-              <a:t>).</a:t>
-            </a:r>
-          </a:p>
-          <a:p>
-            <a:pPr marL="285750" indent="-285750">
-              <a:buFont typeface="Arial"/>
-              <a:buChar char="•"/>
-            </a:pPr>
-            <a:r>
-              <a:rPr lang="en-US" sz="1700" dirty="0">
-                <a:solidFill>
-                  <a:srgbClr val="1E293B"/>
-                </a:solidFill>
-              </a:rPr>
-              <a:t>Melaporkan berkas yang berubah, hilang, dan berkas baru yang mencurigakan.</a:t>
-            </a:r>
-          </a:p>
-          <a:p>
-            <a:pPr marL="285750" indent="-285750">
-              <a:buFont typeface="Arial"/>
-              <a:buChar char="•"/>
-            </a:pPr>
-            <a:r>
-              <a:rPr lang="en-US" sz="1700" dirty="0">
-                <a:solidFill>
-                  <a:srgbClr val="1E293B"/>
-                </a:solidFill>
-              </a:rPr>
-              <a:t>Pemindai webshell di </a:t>
-            </a:r>
-            <a:r>
-              <a:rPr lang="en-US" sz="1600" dirty="0">
-                <a:solidFill>
-                  <a:srgbClr val="0EA5E9"/>
-                </a:solidFill>
-                <a:latin typeface="Consolas"/>
-                <a:cs typeface="Consolas"/>
-              </a:rPr>
-              <a:t>public/</a:t>
-            </a:r>
-            <a:r>
-              <a:rPr lang="en-US" sz="1700" dirty="0">
-                <a:solidFill>
-                  <a:srgbClr val="1E293B"/>
-                </a:solidFill>
-              </a:rPr>
-              <a:t> &amp; </a:t>
-            </a:r>
-            <a:r>
-              <a:rPr lang="en-US" sz="1600" dirty="0">
-                <a:solidFill>
-                  <a:srgbClr val="0EA5E9"/>
-                </a:solidFill>
-                <a:latin typeface="Consolas"/>
-                <a:cs typeface="Consolas"/>
-              </a:rPr>
-              <a:t>storage/</a:t>
-            </a:r>
-            <a:r>
-              <a:rPr lang="en-US" sz="1700" dirty="0">
-                <a:solidFill>
-                  <a:srgbClr val="1E293B"/>
-                </a:solidFill>
-              </a:rPr>
-              <a:t> (b374k, c99, r57, wso, </a:t>
-            </a:r>
-            <a:r>
-              <a:rPr lang="en-US" sz="1600" dirty="0">
-                <a:solidFill>
-                  <a:srgbClr val="0EA5E9"/>
-                </a:solidFill>
-                <a:latin typeface="Consolas"/>
-                <a:cs typeface="Consolas"/>
-              </a:rPr>
-              <a:t>eval(base64_decode()).</a:t>
-            </a:r>
-          </a:p>
-          <a:p>
-            <a:pPr marL="285750" indent="-285750">
-              <a:buFont typeface="Arial"/>
-              <a:buChar char="•"/>
-            </a:pPr>
-            <a:r>
-              <a:rPr lang="en-US" sz="1700" dirty="0">
-                <a:solidFill>
-                  <a:srgbClr val="1E293B"/>
-                </a:solidFill>
-              </a:rPr>
-              <a:t>Penghapusan aman: anti path-traversal, dibatasi </a:t>
-            </a:r>
-            <a:r>
-              <a:rPr lang="en-US" sz="1600" dirty="0">
-                <a:solidFill>
-                  <a:srgbClr val="0EA5E9"/>
-                </a:solidFill>
-                <a:latin typeface="Consolas"/>
-                <a:cs typeface="Consolas"/>
-              </a:rPr>
-              <a:t>base_path()</a:t>
-            </a:r>
-            <a:r>
-              <a:rPr lang="en-US" sz="1700" dirty="0">
-                <a:solidFill>
-                  <a:srgbClr val="1E293B"/>
-                </a:solidFill>
-              </a:rPr>
-              <a:t>, berkas vital dilindungi.</a:t>
+              <a:t>Membaca log Apache/Nginx baris-per-baris via generator — konsumsi RAM stabil di bawah 15 MB.</a:t>
+            </a:r>
+          </a:p>
+          <a:p>
+            <a:pPr marL="285750" indent="-285750">
+              <a:buFont typeface="Arial"/>
+              <a:buChar char="•"/>
+            </a:pPr>
+            <a:r>
+              <a:rPr lang="en-US" sz="1700" dirty="0">
+                <a:solidFill>
+                  <a:srgbClr val="1E293B"/>
+                </a:solidFill>
+              </a:rPr>
+              <a:t>Menangkap penyerang yang ditolak web server sebelum request mencapai PHP.</a:t>
+            </a:r>
+          </a:p>
+          <a:p>
+            <a:pPr marL="285750" indent="-285750">
+              <a:buFont typeface="Arial"/>
+              <a:buChar char="•"/>
+            </a:pPr>
+            <a:r>
+              <a:rPr lang="en-US" sz="1700" dirty="0">
+                <a:solidFill>
+                  <a:srgbClr val="1E293B"/>
+                </a:solidFill>
+              </a:rPr>
+              <a:t>Auto-block IP langsung dari log mentah.</a:t>
+            </a:r>
+          </a:p>
+          <a:p>
+            <a:pPr marL="285750" indent="-285750">
+              <a:buFont typeface="Arial"/>
+              <a:buChar char="•"/>
+            </a:pPr>
+            <a:r>
+              <a:rPr lang="en-US" sz="1700" dirty="0">
+                <a:solidFill>
+                  <a:srgbClr val="1E293B"/>
+                </a:solidFill>
+              </a:rPr>
+              <a:t>Dijadwalkan harian (cron) melalui Laravel Scheduler.</a:t>
             </a:r>
           </a:p>
         </p:txBody>

</xml_diff>